<commit_message>
feat(simulador): 2 modos limpios (RRHH y Tecnico), inicio conversacional con saludo, remocion de avisos de base de datos y modulo CRUD de usuarios
</commit_message>
<xml_diff>
--- a/PITCH PRESENTACIÓN FINAL.pptx
+++ b/PITCH PRESENTACIÓN FINAL.pptx
@@ -121,6 +121,58 @@
     </p:ext>
   </p:extLst>
 </p:presentation>
+</file>
+
+<file path=ppt/revisionInfo.xml><?xml version="1.0" encoding="utf-8"?>
+<p1510:revInfo xmlns:a="http://schemas.openxmlformats.org/drawingml/2006/main" xmlns:r="http://schemas.openxmlformats.org/officeDocument/2006/relationships" xmlns:p1510="http://schemas.microsoft.com/office/powerpoint/2015/10/main">
+  <p1510:revLst>
+    <p1510:client id="{11440CF3-FD6D-419F-B4D0-04E5B2AF9F59}" v="1" dt="2026-10-26T03:54:39.973"/>
+  </p1510:revLst>
+</p1510:revInfo>
+</file>
+
+<file path=ppt/changesInfos/changesInfo1.xml><?xml version="1.0" encoding="utf-8"?>
+<pc:chgInfo xmlns:a="http://schemas.openxmlformats.org/drawingml/2006/main" xmlns:r="http://schemas.openxmlformats.org/officeDocument/2006/relationships" xmlns:ac="http://schemas.microsoft.com/office/drawing/2013/main/command" xmlns:pc="http://schemas.microsoft.com/office/powerpoint/2013/main/command">
+  <pc:docChgLst>
+    <pc:chgData name="Diego Tapia Salazar" userId="c3d00bcd4006f853" providerId="LiveId" clId="{2F6D9AE4-852D-4580-BFBD-4043B69AEE08}"/>
+    <pc:docChg chg="modSld">
+      <pc:chgData name="Diego Tapia Salazar" userId="c3d00bcd4006f853" providerId="LiveId" clId="{2F6D9AE4-852D-4580-BFBD-4043B69AEE08}" dt="2026-10-26T03:56:49.457" v="16" actId="14100"/>
+      <pc:docMkLst>
+        <pc:docMk/>
+      </pc:docMkLst>
+      <pc:sldChg chg="modSp mod">
+        <pc:chgData name="Diego Tapia Salazar" userId="c3d00bcd4006f853" providerId="LiveId" clId="{2F6D9AE4-852D-4580-BFBD-4043B69AEE08}" dt="2026-10-26T03:55:24.523" v="15" actId="20577"/>
+        <pc:sldMkLst>
+          <pc:docMk/>
+          <pc:sldMk cId="1505387986" sldId="258"/>
+        </pc:sldMkLst>
+        <pc:spChg chg="mod">
+          <ac:chgData name="Diego Tapia Salazar" userId="c3d00bcd4006f853" providerId="LiveId" clId="{2F6D9AE4-852D-4580-BFBD-4043B69AEE08}" dt="2026-10-26T03:55:24.523" v="15" actId="20577"/>
+          <ac:spMkLst>
+            <pc:docMk/>
+            <pc:sldMk cId="1505387986" sldId="258"/>
+            <ac:spMk id="8" creationId="{A1ADAF66-BBF4-2551-FEBA-8696230E3334}"/>
+          </ac:spMkLst>
+        </pc:spChg>
+      </pc:sldChg>
+      <pc:sldChg chg="modSp mod">
+        <pc:chgData name="Diego Tapia Salazar" userId="c3d00bcd4006f853" providerId="LiveId" clId="{2F6D9AE4-852D-4580-BFBD-4043B69AEE08}" dt="2026-10-26T03:56:49.457" v="16" actId="14100"/>
+        <pc:sldMkLst>
+          <pc:docMk/>
+          <pc:sldMk cId="3337777894" sldId="259"/>
+        </pc:sldMkLst>
+        <pc:spChg chg="mod">
+          <ac:chgData name="Diego Tapia Salazar" userId="c3d00bcd4006f853" providerId="LiveId" clId="{2F6D9AE4-852D-4580-BFBD-4043B69AEE08}" dt="2026-10-26T03:56:49.457" v="16" actId="14100"/>
+          <ac:spMkLst>
+            <pc:docMk/>
+            <pc:sldMk cId="3337777894" sldId="259"/>
+            <ac:spMk id="5" creationId="{EE565427-C35C-C4BC-80D7-BDEEBD856B23}"/>
+          </ac:spMkLst>
+        </pc:spChg>
+      </pc:sldChg>
+    </pc:docChg>
+  </pc:docChgLst>
+</pc:chgInfo>
 </file>
 
 <file path=ppt/diagrams/colors1.xml><?xml version="1.0" encoding="utf-8"?>
@@ -1412,13 +1464,6 @@
         </dgm:presLayoutVars>
       </dgm:prSet>
       <dgm:spPr/>
-      <dgm:t>
-        <a:bodyPr/>
-        <a:lstStyle/>
-        <a:p>
-          <a:endParaRPr lang="es-ES"/>
-        </a:p>
-      </dgm:t>
     </dgm:pt>
     <dgm:pt modelId="{7553334A-46BC-496D-AD66-04BC3B4CFE45}" type="pres">
       <dgm:prSet presAssocID="{A7C14BFC-42FD-484E-A7DC-C81B0C13922D}" presName="dummy" presStyleCnt="0"/>
@@ -1431,24 +1476,10 @@
         </dgm:presLayoutVars>
       </dgm:prSet>
       <dgm:spPr/>
-      <dgm:t>
-        <a:bodyPr/>
-        <a:lstStyle/>
-        <a:p>
-          <a:endParaRPr lang="es-ES"/>
-        </a:p>
-      </dgm:t>
     </dgm:pt>
     <dgm:pt modelId="{6E13AB0A-5338-43D8-B58F-44F7F16C54D7}" type="pres">
       <dgm:prSet presAssocID="{3E45865D-2544-4A4A-824E-AB2F19DC12D1}" presName="sibTrans" presStyleLbl="node1" presStyleIdx="0" presStyleCnt="10"/>
       <dgm:spPr/>
-      <dgm:t>
-        <a:bodyPr/>
-        <a:lstStyle/>
-        <a:p>
-          <a:endParaRPr lang="es-ES"/>
-        </a:p>
-      </dgm:t>
     </dgm:pt>
     <dgm:pt modelId="{01F90C7E-170C-408F-BBD0-08B3EC1512B8}" type="pres">
       <dgm:prSet presAssocID="{034CDE8E-B2A9-4E1E-B64A-904B09C20502}" presName="dummy" presStyleCnt="0"/>
@@ -1461,24 +1492,10 @@
         </dgm:presLayoutVars>
       </dgm:prSet>
       <dgm:spPr/>
-      <dgm:t>
-        <a:bodyPr/>
-        <a:lstStyle/>
-        <a:p>
-          <a:endParaRPr lang="es-ES"/>
-        </a:p>
-      </dgm:t>
     </dgm:pt>
     <dgm:pt modelId="{C5A28ECE-5F95-4A81-8113-75DC5544F906}" type="pres">
       <dgm:prSet presAssocID="{898D1AD8-C62B-4760-BBB3-CFFA028EEDA8}" presName="sibTrans" presStyleLbl="node1" presStyleIdx="1" presStyleCnt="10"/>
       <dgm:spPr/>
-      <dgm:t>
-        <a:bodyPr/>
-        <a:lstStyle/>
-        <a:p>
-          <a:endParaRPr lang="es-ES"/>
-        </a:p>
-      </dgm:t>
     </dgm:pt>
     <dgm:pt modelId="{88C4B6AB-74EB-4C33-AEC2-F873BE56C77E}" type="pres">
       <dgm:prSet presAssocID="{187513CB-0041-48B1-8C3C-3793F176A38C}" presName="dummy" presStyleCnt="0"/>
@@ -1491,24 +1508,10 @@
         </dgm:presLayoutVars>
       </dgm:prSet>
       <dgm:spPr/>
-      <dgm:t>
-        <a:bodyPr/>
-        <a:lstStyle/>
-        <a:p>
-          <a:endParaRPr lang="es-ES"/>
-        </a:p>
-      </dgm:t>
     </dgm:pt>
     <dgm:pt modelId="{4CFAF20E-2CE9-410D-8C4F-99A003CC7A05}" type="pres">
       <dgm:prSet presAssocID="{91AF92F1-664C-44A9-A9AF-60B4FDE9F772}" presName="sibTrans" presStyleLbl="node1" presStyleIdx="2" presStyleCnt="10"/>
       <dgm:spPr/>
-      <dgm:t>
-        <a:bodyPr/>
-        <a:lstStyle/>
-        <a:p>
-          <a:endParaRPr lang="es-ES"/>
-        </a:p>
-      </dgm:t>
     </dgm:pt>
     <dgm:pt modelId="{14BA54F5-845B-4279-9CE6-EE3BF42F5D6D}" type="pres">
       <dgm:prSet presAssocID="{D45A3878-E47B-4C2C-B18F-233FC4AF1D5A}" presName="dummy" presStyleCnt="0"/>
@@ -1521,24 +1524,10 @@
         </dgm:presLayoutVars>
       </dgm:prSet>
       <dgm:spPr/>
-      <dgm:t>
-        <a:bodyPr/>
-        <a:lstStyle/>
-        <a:p>
-          <a:endParaRPr lang="es-ES"/>
-        </a:p>
-      </dgm:t>
     </dgm:pt>
     <dgm:pt modelId="{AC31F8FC-833D-4CF5-AD19-1119055ECA89}" type="pres">
       <dgm:prSet presAssocID="{8EAD4F29-F68F-440D-BADC-DC6F8819E824}" presName="sibTrans" presStyleLbl="node1" presStyleIdx="3" presStyleCnt="10"/>
       <dgm:spPr/>
-      <dgm:t>
-        <a:bodyPr/>
-        <a:lstStyle/>
-        <a:p>
-          <a:endParaRPr lang="es-ES"/>
-        </a:p>
-      </dgm:t>
     </dgm:pt>
     <dgm:pt modelId="{4196D907-CD02-48D9-B960-003FFDCA0085}" type="pres">
       <dgm:prSet presAssocID="{1A7A6048-8D1E-4CCB-AB57-A75B91002020}" presName="dummy" presStyleCnt="0"/>
@@ -1551,24 +1540,10 @@
         </dgm:presLayoutVars>
       </dgm:prSet>
       <dgm:spPr/>
-      <dgm:t>
-        <a:bodyPr/>
-        <a:lstStyle/>
-        <a:p>
-          <a:endParaRPr lang="es-ES"/>
-        </a:p>
-      </dgm:t>
     </dgm:pt>
     <dgm:pt modelId="{08A8699B-3356-4B7B-86C7-BB255DDA25C7}" type="pres">
       <dgm:prSet presAssocID="{479B4475-028B-49AA-B2F9-90BDBEE58BE0}" presName="sibTrans" presStyleLbl="node1" presStyleIdx="4" presStyleCnt="10"/>
       <dgm:spPr/>
-      <dgm:t>
-        <a:bodyPr/>
-        <a:lstStyle/>
-        <a:p>
-          <a:endParaRPr lang="es-ES"/>
-        </a:p>
-      </dgm:t>
     </dgm:pt>
     <dgm:pt modelId="{2D917792-A278-42C5-B9B9-E43B90B8C142}" type="pres">
       <dgm:prSet presAssocID="{5A04C44D-C0E1-4B13-8EC9-A0528D875B47}" presName="dummy" presStyleCnt="0"/>
@@ -1581,24 +1556,10 @@
         </dgm:presLayoutVars>
       </dgm:prSet>
       <dgm:spPr/>
-      <dgm:t>
-        <a:bodyPr/>
-        <a:lstStyle/>
-        <a:p>
-          <a:endParaRPr lang="es-ES"/>
-        </a:p>
-      </dgm:t>
     </dgm:pt>
     <dgm:pt modelId="{DC6AC8A5-37C0-4DE2-B2BE-410A5BFD8F16}" type="pres">
       <dgm:prSet presAssocID="{B353A3A0-4BB2-47F8-8660-F5F68DEBB45B}" presName="sibTrans" presStyleLbl="node1" presStyleIdx="5" presStyleCnt="10" custScaleX="120544" custScaleY="96035"/>
       <dgm:spPr/>
-      <dgm:t>
-        <a:bodyPr/>
-        <a:lstStyle/>
-        <a:p>
-          <a:endParaRPr lang="es-ES"/>
-        </a:p>
-      </dgm:t>
     </dgm:pt>
     <dgm:pt modelId="{2F0D8111-9349-4F5B-A135-6790DAD0F65C}" type="pres">
       <dgm:prSet presAssocID="{DDF5495A-ED8F-4CBF-90AA-52E91B0F974D}" presName="dummy" presStyleCnt="0"/>
@@ -1611,24 +1572,10 @@
         </dgm:presLayoutVars>
       </dgm:prSet>
       <dgm:spPr/>
-      <dgm:t>
-        <a:bodyPr/>
-        <a:lstStyle/>
-        <a:p>
-          <a:endParaRPr lang="es-ES"/>
-        </a:p>
-      </dgm:t>
     </dgm:pt>
     <dgm:pt modelId="{0D57837E-456A-47B7-93E4-3ADD42796347}" type="pres">
       <dgm:prSet presAssocID="{2643CB98-36A8-4012-B2DC-54D795A23F8E}" presName="sibTrans" presStyleLbl="node1" presStyleIdx="6" presStyleCnt="10"/>
       <dgm:spPr/>
-      <dgm:t>
-        <a:bodyPr/>
-        <a:lstStyle/>
-        <a:p>
-          <a:endParaRPr lang="es-ES"/>
-        </a:p>
-      </dgm:t>
     </dgm:pt>
     <dgm:pt modelId="{C5460AA0-0973-44A5-A62B-DF756CD6918B}" type="pres">
       <dgm:prSet presAssocID="{6BE05E82-0788-434F-8F1F-766CCBB53E26}" presName="dummy" presStyleCnt="0"/>
@@ -1641,24 +1588,10 @@
         </dgm:presLayoutVars>
       </dgm:prSet>
       <dgm:spPr/>
-      <dgm:t>
-        <a:bodyPr/>
-        <a:lstStyle/>
-        <a:p>
-          <a:endParaRPr lang="es-ES"/>
-        </a:p>
-      </dgm:t>
     </dgm:pt>
     <dgm:pt modelId="{D0D498C8-D633-4DAB-A232-DDE8FFFB5F15}" type="pres">
       <dgm:prSet presAssocID="{CBBF1D43-21BB-410C-AC6C-70C1D793650C}" presName="sibTrans" presStyleLbl="node1" presStyleIdx="7" presStyleCnt="10"/>
       <dgm:spPr/>
-      <dgm:t>
-        <a:bodyPr/>
-        <a:lstStyle/>
-        <a:p>
-          <a:endParaRPr lang="es-ES"/>
-        </a:p>
-      </dgm:t>
     </dgm:pt>
     <dgm:pt modelId="{61420328-E97A-4C20-AE5E-71DE1D92F3FB}" type="pres">
       <dgm:prSet presAssocID="{2876A3AF-B4F2-4DB1-8BAA-28B5221EB7CB}" presName="dummy" presStyleCnt="0"/>
@@ -1671,24 +1604,10 @@
         </dgm:presLayoutVars>
       </dgm:prSet>
       <dgm:spPr/>
-      <dgm:t>
-        <a:bodyPr/>
-        <a:lstStyle/>
-        <a:p>
-          <a:endParaRPr lang="es-ES"/>
-        </a:p>
-      </dgm:t>
     </dgm:pt>
     <dgm:pt modelId="{B33A4974-B8FC-4117-BB7D-FCAC4975A154}" type="pres">
       <dgm:prSet presAssocID="{A2344B46-04F2-4FB8-876F-797A525BBF96}" presName="sibTrans" presStyleLbl="node1" presStyleIdx="8" presStyleCnt="10"/>
       <dgm:spPr/>
-      <dgm:t>
-        <a:bodyPr/>
-        <a:lstStyle/>
-        <a:p>
-          <a:endParaRPr lang="es-ES"/>
-        </a:p>
-      </dgm:t>
     </dgm:pt>
     <dgm:pt modelId="{DFE84411-DF4A-4838-B368-37F058FB850F}" type="pres">
       <dgm:prSet presAssocID="{A6444D54-FA08-4C85-877A-BC5406CF4EBD}" presName="dummy" presStyleCnt="0"/>
@@ -1701,58 +1620,44 @@
         </dgm:presLayoutVars>
       </dgm:prSet>
       <dgm:spPr/>
-      <dgm:t>
-        <a:bodyPr/>
-        <a:lstStyle/>
-        <a:p>
-          <a:endParaRPr lang="es-ES"/>
-        </a:p>
-      </dgm:t>
     </dgm:pt>
     <dgm:pt modelId="{967C72B1-2C49-4884-AC8E-83A3A1C4B2E6}" type="pres">
       <dgm:prSet presAssocID="{39EECDCD-7E5A-49DB-BF25-D0428A85E907}" presName="sibTrans" presStyleLbl="node1" presStyleIdx="9" presStyleCnt="10"/>
       <dgm:spPr/>
-      <dgm:t>
-        <a:bodyPr/>
-        <a:lstStyle/>
-        <a:p>
-          <a:endParaRPr lang="es-ES"/>
-        </a:p>
-      </dgm:t>
     </dgm:pt>
   </dgm:ptLst>
   <dgm:cxnLst>
+    <dgm:cxn modelId="{52915F01-4A3E-45AE-8B8A-7CF962986823}" type="presOf" srcId="{DDF5495A-ED8F-4CBF-90AA-52E91B0F974D}" destId="{30E18A30-8612-448E-9FCD-A4E8B810D55A}" srcOrd="0" destOrd="0" presId="urn:microsoft.com/office/officeart/2005/8/layout/cycle1"/>
+    <dgm:cxn modelId="{D70C1D1C-0F1F-4E43-B064-500B47324612}" srcId="{05E15462-8F3D-4C51-9038-72DEFD295ECB}" destId="{5A04C44D-C0E1-4B13-8EC9-A0528D875B47}" srcOrd="5" destOrd="0" parTransId="{735D546D-7B51-4C90-B5B8-F431DF17EC4C}" sibTransId="{B353A3A0-4BB2-47F8-8660-F5F68DEBB45B}"/>
+    <dgm:cxn modelId="{C0A0F42D-308F-4B81-8F79-03A4FF870FBE}" type="presOf" srcId="{6BE05E82-0788-434F-8F1F-766CCBB53E26}" destId="{BDBA44C2-FAC8-4B97-8397-316AEF75DF95}" srcOrd="0" destOrd="0" presId="urn:microsoft.com/office/officeart/2005/8/layout/cycle1"/>
+    <dgm:cxn modelId="{B1334330-C25C-4CF3-A6A6-424738A9FF83}" type="presOf" srcId="{91AF92F1-664C-44A9-A9AF-60B4FDE9F772}" destId="{4CFAF20E-2CE9-410D-8C4F-99A003CC7A05}" srcOrd="0" destOrd="0" presId="urn:microsoft.com/office/officeart/2005/8/layout/cycle1"/>
+    <dgm:cxn modelId="{74320E36-F702-4786-B766-631E0F214044}" type="presOf" srcId="{479B4475-028B-49AA-B2F9-90BDBEE58BE0}" destId="{08A8699B-3356-4B7B-86C7-BB255DDA25C7}" srcOrd="0" destOrd="0" presId="urn:microsoft.com/office/officeart/2005/8/layout/cycle1"/>
+    <dgm:cxn modelId="{B0A2A037-E134-479E-9CD9-D9A7841A09AA}" type="presOf" srcId="{CBBF1D43-21BB-410C-AC6C-70C1D793650C}" destId="{D0D498C8-D633-4DAB-A232-DDE8FFFB5F15}" srcOrd="0" destOrd="0" presId="urn:microsoft.com/office/officeart/2005/8/layout/cycle1"/>
+    <dgm:cxn modelId="{5A89F13C-9BCA-4CD1-85EA-B724B4EB9A5B}" srcId="{05E15462-8F3D-4C51-9038-72DEFD295ECB}" destId="{DDF5495A-ED8F-4CBF-90AA-52E91B0F974D}" srcOrd="6" destOrd="0" parTransId="{A2C3A9C1-39B3-4E11-A150-A9597BD5F3A5}" sibTransId="{2643CB98-36A8-4012-B2DC-54D795A23F8E}"/>
+    <dgm:cxn modelId="{374C495C-83C5-49A4-B278-9D6EEC42597B}" type="presOf" srcId="{A7C14BFC-42FD-484E-A7DC-C81B0C13922D}" destId="{3B3F15E8-7D55-4FC5-BDE6-E09F64430BA7}" srcOrd="0" destOrd="0" presId="urn:microsoft.com/office/officeart/2005/8/layout/cycle1"/>
+    <dgm:cxn modelId="{B6CFFF5C-1847-43B3-A3A4-689062C97691}" srcId="{05E15462-8F3D-4C51-9038-72DEFD295ECB}" destId="{A7C14BFC-42FD-484E-A7DC-C81B0C13922D}" srcOrd="0" destOrd="0" parTransId="{484E0BE8-1F82-4C49-81A1-CA7D3184A632}" sibTransId="{3E45865D-2544-4A4A-824E-AB2F19DC12D1}"/>
+    <dgm:cxn modelId="{3FADF241-E85F-479F-9D2B-DDF757CB2D3D}" type="presOf" srcId="{1A7A6048-8D1E-4CCB-AB57-A75B91002020}" destId="{DC19223B-BA97-489C-9FA1-B5820447A0A9}" srcOrd="0" destOrd="0" presId="urn:microsoft.com/office/officeart/2005/8/layout/cycle1"/>
+    <dgm:cxn modelId="{78994D67-6C56-42AA-9A92-74B9562778D0}" type="presOf" srcId="{3E45865D-2544-4A4A-824E-AB2F19DC12D1}" destId="{6E13AB0A-5338-43D8-B58F-44F7F16C54D7}" srcOrd="0" destOrd="0" presId="urn:microsoft.com/office/officeart/2005/8/layout/cycle1"/>
     <dgm:cxn modelId="{188F5469-7F54-45AE-8DCF-81C2C30149EF}" srcId="{05E15462-8F3D-4C51-9038-72DEFD295ECB}" destId="{1A7A6048-8D1E-4CCB-AB57-A75B91002020}" srcOrd="4" destOrd="0" parTransId="{3C61DCC7-D067-4AF7-B323-CA19CC6FC2D1}" sibTransId="{479B4475-028B-49AA-B2F9-90BDBEE58BE0}"/>
-    <dgm:cxn modelId="{B1334330-C25C-4CF3-A6A6-424738A9FF83}" type="presOf" srcId="{91AF92F1-664C-44A9-A9AF-60B4FDE9F772}" destId="{4CFAF20E-2CE9-410D-8C4F-99A003CC7A05}" srcOrd="0" destOrd="0" presId="urn:microsoft.com/office/officeart/2005/8/layout/cycle1"/>
+    <dgm:cxn modelId="{FD37194A-24B4-41AB-A8E5-5BBEE7002A7C}" type="presOf" srcId="{5A04C44D-C0E1-4B13-8EC9-A0528D875B47}" destId="{2959AFB0-C8CA-4E0A-A53F-203C7FFFBF0A}" srcOrd="0" destOrd="0" presId="urn:microsoft.com/office/officeart/2005/8/layout/cycle1"/>
+    <dgm:cxn modelId="{A733A46A-4896-4752-9173-DAC184FAF02B}" type="presOf" srcId="{034CDE8E-B2A9-4E1E-B64A-904B09C20502}" destId="{420BD5EA-43B2-44FA-8803-BCC6A1A5A971}" srcOrd="0" destOrd="0" presId="urn:microsoft.com/office/officeart/2005/8/layout/cycle1"/>
     <dgm:cxn modelId="{3839C451-7E83-4F7B-9F86-51C82D303344}" type="presOf" srcId="{2876A3AF-B4F2-4DB1-8BAA-28B5221EB7CB}" destId="{FEF4C21C-9519-4E2B-BDEC-2672152CB9DB}" srcOrd="0" destOrd="0" presId="urn:microsoft.com/office/officeart/2005/8/layout/cycle1"/>
-    <dgm:cxn modelId="{C0A0F42D-308F-4B81-8F79-03A4FF870FBE}" type="presOf" srcId="{6BE05E82-0788-434F-8F1F-766CCBB53E26}" destId="{BDBA44C2-FAC8-4B97-8397-316AEF75DF95}" srcOrd="0" destOrd="0" presId="urn:microsoft.com/office/officeart/2005/8/layout/cycle1"/>
-    <dgm:cxn modelId="{D70C1D1C-0F1F-4E43-B064-500B47324612}" srcId="{05E15462-8F3D-4C51-9038-72DEFD295ECB}" destId="{5A04C44D-C0E1-4B13-8EC9-A0528D875B47}" srcOrd="5" destOrd="0" parTransId="{735D546D-7B51-4C90-B5B8-F431DF17EC4C}" sibTransId="{B353A3A0-4BB2-47F8-8660-F5F68DEBB45B}"/>
+    <dgm:cxn modelId="{A5406953-5106-41EF-9E33-1E3B02EF1D24}" srcId="{05E15462-8F3D-4C51-9038-72DEFD295ECB}" destId="{034CDE8E-B2A9-4E1E-B64A-904B09C20502}" srcOrd="1" destOrd="0" parTransId="{FD32B512-4431-4188-B4A6-1348AB03D760}" sibTransId="{898D1AD8-C62B-4760-BBB3-CFFA028EEDA8}"/>
+    <dgm:cxn modelId="{2DC2AB74-D75D-4802-98C9-690EF6EE66F8}" type="presOf" srcId="{D45A3878-E47B-4C2C-B18F-233FC4AF1D5A}" destId="{9D700E5C-BD52-44F7-8383-C15FE2812038}" srcOrd="0" destOrd="0" presId="urn:microsoft.com/office/officeart/2005/8/layout/cycle1"/>
+    <dgm:cxn modelId="{8E0B1759-B891-4C54-B572-0D751DB9C1B8}" type="presOf" srcId="{2643CB98-36A8-4012-B2DC-54D795A23F8E}" destId="{0D57837E-456A-47B7-93E4-3ADD42796347}" srcOrd="0" destOrd="0" presId="urn:microsoft.com/office/officeart/2005/8/layout/cycle1"/>
+    <dgm:cxn modelId="{215C5279-BEE9-4936-9FAA-B984C3BE419E}" type="presOf" srcId="{A6444D54-FA08-4C85-877A-BC5406CF4EBD}" destId="{D5A464D3-EE9A-402A-B509-F4AF5037A84F}" srcOrd="0" destOrd="0" presId="urn:microsoft.com/office/officeart/2005/8/layout/cycle1"/>
+    <dgm:cxn modelId="{A2BB935A-1673-4E24-9772-4C44973FA503}" srcId="{05E15462-8F3D-4C51-9038-72DEFD295ECB}" destId="{2876A3AF-B4F2-4DB1-8BAA-28B5221EB7CB}" srcOrd="8" destOrd="0" parTransId="{A54849D3-978E-4AEF-BE10-1000943F0C62}" sibTransId="{A2344B46-04F2-4FB8-876F-797A525BBF96}"/>
     <dgm:cxn modelId="{0CE4E77E-D2ED-4B9E-9887-45E6045A1D33}" type="presOf" srcId="{05E15462-8F3D-4C51-9038-72DEFD295ECB}" destId="{5724728F-2991-471C-8F3E-8655C7CF9A7F}" srcOrd="0" destOrd="0" presId="urn:microsoft.com/office/officeart/2005/8/layout/cycle1"/>
-    <dgm:cxn modelId="{74320E36-F702-4786-B766-631E0F214044}" type="presOf" srcId="{479B4475-028B-49AA-B2F9-90BDBEE58BE0}" destId="{08A8699B-3356-4B7B-86C7-BB255DDA25C7}" srcOrd="0" destOrd="0" presId="urn:microsoft.com/office/officeart/2005/8/layout/cycle1"/>
-    <dgm:cxn modelId="{5A89F13C-9BCA-4CD1-85EA-B724B4EB9A5B}" srcId="{05E15462-8F3D-4C51-9038-72DEFD295ECB}" destId="{DDF5495A-ED8F-4CBF-90AA-52E91B0F974D}" srcOrd="6" destOrd="0" parTransId="{A2C3A9C1-39B3-4E11-A150-A9597BD5F3A5}" sibTransId="{2643CB98-36A8-4012-B2DC-54D795A23F8E}"/>
-    <dgm:cxn modelId="{2DC2AB74-D75D-4802-98C9-690EF6EE66F8}" type="presOf" srcId="{D45A3878-E47B-4C2C-B18F-233FC4AF1D5A}" destId="{9D700E5C-BD52-44F7-8383-C15FE2812038}" srcOrd="0" destOrd="0" presId="urn:microsoft.com/office/officeart/2005/8/layout/cycle1"/>
-    <dgm:cxn modelId="{B6CFFF5C-1847-43B3-A3A4-689062C97691}" srcId="{05E15462-8F3D-4C51-9038-72DEFD295ECB}" destId="{A7C14BFC-42FD-484E-A7DC-C81B0C13922D}" srcOrd="0" destOrd="0" parTransId="{484E0BE8-1F82-4C49-81A1-CA7D3184A632}" sibTransId="{3E45865D-2544-4A4A-824E-AB2F19DC12D1}"/>
-    <dgm:cxn modelId="{FD37194A-24B4-41AB-A8E5-5BBEE7002A7C}" type="presOf" srcId="{5A04C44D-C0E1-4B13-8EC9-A0528D875B47}" destId="{2959AFB0-C8CA-4E0A-A53F-203C7FFFBF0A}" srcOrd="0" destOrd="0" presId="urn:microsoft.com/office/officeart/2005/8/layout/cycle1"/>
-    <dgm:cxn modelId="{215C5279-BEE9-4936-9FAA-B984C3BE419E}" type="presOf" srcId="{A6444D54-FA08-4C85-877A-BC5406CF4EBD}" destId="{D5A464D3-EE9A-402A-B509-F4AF5037A84F}" srcOrd="0" destOrd="0" presId="urn:microsoft.com/office/officeart/2005/8/layout/cycle1"/>
-    <dgm:cxn modelId="{57E73DAD-0F8D-4CD5-B8E0-F245037A796D}" type="presOf" srcId="{39EECDCD-7E5A-49DB-BF25-D0428A85E907}" destId="{967C72B1-2C49-4884-AC8E-83A3A1C4B2E6}" srcOrd="0" destOrd="0" presId="urn:microsoft.com/office/officeart/2005/8/layout/cycle1"/>
-    <dgm:cxn modelId="{A5406953-5106-41EF-9E33-1E3B02EF1D24}" srcId="{05E15462-8F3D-4C51-9038-72DEFD295ECB}" destId="{034CDE8E-B2A9-4E1E-B64A-904B09C20502}" srcOrd="1" destOrd="0" parTransId="{FD32B512-4431-4188-B4A6-1348AB03D760}" sibTransId="{898D1AD8-C62B-4760-BBB3-CFFA028EEDA8}"/>
-    <dgm:cxn modelId="{3FADF241-E85F-479F-9D2B-DDF757CB2D3D}" type="presOf" srcId="{1A7A6048-8D1E-4CCB-AB57-A75B91002020}" destId="{DC19223B-BA97-489C-9FA1-B5820447A0A9}" srcOrd="0" destOrd="0" presId="urn:microsoft.com/office/officeart/2005/8/layout/cycle1"/>
-    <dgm:cxn modelId="{B0A2A037-E134-479E-9CD9-D9A7841A09AA}" type="presOf" srcId="{CBBF1D43-21BB-410C-AC6C-70C1D793650C}" destId="{D0D498C8-D633-4DAB-A232-DDE8FFFB5F15}" srcOrd="0" destOrd="0" presId="urn:microsoft.com/office/officeart/2005/8/layout/cycle1"/>
-    <dgm:cxn modelId="{A733A46A-4896-4752-9173-DAC184FAF02B}" type="presOf" srcId="{034CDE8E-B2A9-4E1E-B64A-904B09C20502}" destId="{420BD5EA-43B2-44FA-8803-BCC6A1A5A971}" srcOrd="0" destOrd="0" presId="urn:microsoft.com/office/officeart/2005/8/layout/cycle1"/>
-    <dgm:cxn modelId="{F247B1B7-04EB-4A35-A411-4EEADA22E529}" type="presOf" srcId="{187513CB-0041-48B1-8C3C-3793F176A38C}" destId="{9777A358-330E-42F4-A39C-90DE533A7C5A}" srcOrd="0" destOrd="0" presId="urn:microsoft.com/office/officeart/2005/8/layout/cycle1"/>
-    <dgm:cxn modelId="{A2BB935A-1673-4E24-9772-4C44973FA503}" srcId="{05E15462-8F3D-4C51-9038-72DEFD295ECB}" destId="{2876A3AF-B4F2-4DB1-8BAA-28B5221EB7CB}" srcOrd="8" destOrd="0" parTransId="{A54849D3-978E-4AEF-BE10-1000943F0C62}" sibTransId="{A2344B46-04F2-4FB8-876F-797A525BBF96}"/>
-    <dgm:cxn modelId="{78994D67-6C56-42AA-9A92-74B9562778D0}" type="presOf" srcId="{3E45865D-2544-4A4A-824E-AB2F19DC12D1}" destId="{6E13AB0A-5338-43D8-B58F-44F7F16C54D7}" srcOrd="0" destOrd="0" presId="urn:microsoft.com/office/officeart/2005/8/layout/cycle1"/>
-    <dgm:cxn modelId="{374C495C-83C5-49A4-B278-9D6EEC42597B}" type="presOf" srcId="{A7C14BFC-42FD-484E-A7DC-C81B0C13922D}" destId="{3B3F15E8-7D55-4FC5-BDE6-E09F64430BA7}" srcOrd="0" destOrd="0" presId="urn:microsoft.com/office/officeart/2005/8/layout/cycle1"/>
-    <dgm:cxn modelId="{8E0B1759-B891-4C54-B572-0D751DB9C1B8}" type="presOf" srcId="{2643CB98-36A8-4012-B2DC-54D795A23F8E}" destId="{0D57837E-456A-47B7-93E4-3ADD42796347}" srcOrd="0" destOrd="0" presId="urn:microsoft.com/office/officeart/2005/8/layout/cycle1"/>
-    <dgm:cxn modelId="{52915F01-4A3E-45AE-8B8A-7CF962986823}" type="presOf" srcId="{DDF5495A-ED8F-4CBF-90AA-52E91B0F974D}" destId="{30E18A30-8612-448E-9FCD-A4E8B810D55A}" srcOrd="0" destOrd="0" presId="urn:microsoft.com/office/officeart/2005/8/layout/cycle1"/>
-    <dgm:cxn modelId="{BF7A8D97-B1E5-4353-B6B3-E3190750EA2D}" srcId="{05E15462-8F3D-4C51-9038-72DEFD295ECB}" destId="{6BE05E82-0788-434F-8F1F-766CCBB53E26}" srcOrd="7" destOrd="0" parTransId="{54298CCB-BB42-4CAF-810E-91D928F773ED}" sibTransId="{CBBF1D43-21BB-410C-AC6C-70C1D793650C}"/>
-    <dgm:cxn modelId="{B84210D0-4EBE-49B8-B9AC-88A965777B26}" srcId="{05E15462-8F3D-4C51-9038-72DEFD295ECB}" destId="{187513CB-0041-48B1-8C3C-3793F176A38C}" srcOrd="2" destOrd="0" parTransId="{8949FE4E-3294-4BCB-911F-B885278D68F4}" sibTransId="{91AF92F1-664C-44A9-A9AF-60B4FDE9F772}"/>
     <dgm:cxn modelId="{CB50CC8D-C7D1-4E38-831E-CDEF86C13E8C}" type="presOf" srcId="{8EAD4F29-F68F-440D-BADC-DC6F8819E824}" destId="{AC31F8FC-833D-4CF5-AD19-1119055ECA89}" srcOrd="0" destOrd="0" presId="urn:microsoft.com/office/officeart/2005/8/layout/cycle1"/>
     <dgm:cxn modelId="{FB5EAD8E-F514-4B25-9D97-25E3EC28957C}" srcId="{05E15462-8F3D-4C51-9038-72DEFD295ECB}" destId="{A6444D54-FA08-4C85-877A-BC5406CF4EBD}" srcOrd="9" destOrd="0" parTransId="{C3CA1007-15D4-4A5A-8EF1-02556BC02816}" sibTransId="{39EECDCD-7E5A-49DB-BF25-D0428A85E907}"/>
+    <dgm:cxn modelId="{BF7A8D97-B1E5-4353-B6B3-E3190750EA2D}" srcId="{05E15462-8F3D-4C51-9038-72DEFD295ECB}" destId="{6BE05E82-0788-434F-8F1F-766CCBB53E26}" srcOrd="7" destOrd="0" parTransId="{54298CCB-BB42-4CAF-810E-91D928F773ED}" sibTransId="{CBBF1D43-21BB-410C-AC6C-70C1D793650C}"/>
+    <dgm:cxn modelId="{57E73DAD-0F8D-4CD5-B8E0-F245037A796D}" type="presOf" srcId="{39EECDCD-7E5A-49DB-BF25-D0428A85E907}" destId="{967C72B1-2C49-4884-AC8E-83A3A1C4B2E6}" srcOrd="0" destOrd="0" presId="urn:microsoft.com/office/officeart/2005/8/layout/cycle1"/>
     <dgm:cxn modelId="{DEF2CEB0-C617-492D-A263-09E9D26491AC}" type="presOf" srcId="{A2344B46-04F2-4FB8-876F-797A525BBF96}" destId="{B33A4974-B8FC-4117-BB7D-FCAC4975A154}" srcOrd="0" destOrd="0" presId="urn:microsoft.com/office/officeart/2005/8/layout/cycle1"/>
+    <dgm:cxn modelId="{F247B1B7-04EB-4A35-A411-4EEADA22E529}" type="presOf" srcId="{187513CB-0041-48B1-8C3C-3793F176A38C}" destId="{9777A358-330E-42F4-A39C-90DE533A7C5A}" srcOrd="0" destOrd="0" presId="urn:microsoft.com/office/officeart/2005/8/layout/cycle1"/>
+    <dgm:cxn modelId="{B84210D0-4EBE-49B8-B9AC-88A965777B26}" srcId="{05E15462-8F3D-4C51-9038-72DEFD295ECB}" destId="{187513CB-0041-48B1-8C3C-3793F176A38C}" srcOrd="2" destOrd="0" parTransId="{8949FE4E-3294-4BCB-911F-B885278D68F4}" sibTransId="{91AF92F1-664C-44A9-A9AF-60B4FDE9F772}"/>
+    <dgm:cxn modelId="{29E4F4D9-BDB9-46A2-8216-4521AB777B9D}" type="presOf" srcId="{B353A3A0-4BB2-47F8-8660-F5F68DEBB45B}" destId="{DC6AC8A5-37C0-4DE2-B2BE-410A5BFD8F16}" srcOrd="0" destOrd="0" presId="urn:microsoft.com/office/officeart/2005/8/layout/cycle1"/>
+    <dgm:cxn modelId="{5115A6E9-2FFF-47C6-AB56-15619D9E2535}" type="presOf" srcId="{898D1AD8-C62B-4760-BBB3-CFFA028EEDA8}" destId="{C5A28ECE-5F95-4A81-8113-75DC5544F906}" srcOrd="0" destOrd="0" presId="urn:microsoft.com/office/officeart/2005/8/layout/cycle1"/>
     <dgm:cxn modelId="{51B3C9F0-8E8E-4FE5-9511-181A3FB4A370}" srcId="{05E15462-8F3D-4C51-9038-72DEFD295ECB}" destId="{D45A3878-E47B-4C2C-B18F-233FC4AF1D5A}" srcOrd="3" destOrd="0" parTransId="{07C9023C-5154-403C-AB0D-AA5FE36D9AC7}" sibTransId="{8EAD4F29-F68F-440D-BADC-DC6F8819E824}"/>
-    <dgm:cxn modelId="{5115A6E9-2FFF-47C6-AB56-15619D9E2535}" type="presOf" srcId="{898D1AD8-C62B-4760-BBB3-CFFA028EEDA8}" destId="{C5A28ECE-5F95-4A81-8113-75DC5544F906}" srcOrd="0" destOrd="0" presId="urn:microsoft.com/office/officeart/2005/8/layout/cycle1"/>
-    <dgm:cxn modelId="{29E4F4D9-BDB9-46A2-8216-4521AB777B9D}" type="presOf" srcId="{B353A3A0-4BB2-47F8-8660-F5F68DEBB45B}" destId="{DC6AC8A5-37C0-4DE2-B2BE-410A5BFD8F16}" srcOrd="0" destOrd="0" presId="urn:microsoft.com/office/officeart/2005/8/layout/cycle1"/>
     <dgm:cxn modelId="{ACDF6AC7-CEC5-4AF3-A75A-6A31F2A785EF}" type="presParOf" srcId="{5724728F-2991-471C-8F3E-8655C7CF9A7F}" destId="{7553334A-46BC-496D-AD66-04BC3B4CFE45}" srcOrd="0" destOrd="0" presId="urn:microsoft.com/office/officeart/2005/8/layout/cycle1"/>
     <dgm:cxn modelId="{EA6E3C76-E4EE-40E5-86FA-548EA61427D0}" type="presParOf" srcId="{5724728F-2991-471C-8F3E-8655C7CF9A7F}" destId="{3B3F15E8-7D55-4FC5-BDE6-E09F64430BA7}" srcOrd="1" destOrd="0" presId="urn:microsoft.com/office/officeart/2005/8/layout/cycle1"/>
     <dgm:cxn modelId="{42A3FE92-F76A-4503-9DE0-6028E5F680CC}" type="presParOf" srcId="{5724728F-2991-471C-8F3E-8655C7CF9A7F}" destId="{6E13AB0A-5338-43D8-B58F-44F7F16C54D7}" srcOrd="2" destOrd="0" presId="urn:microsoft.com/office/officeart/2005/8/layout/cycle1"/>
@@ -1839,7 +1744,7 @@
         </a:bodyPr>
         <a:lstStyle/>
         <a:p>
-          <a:pPr lvl="0" algn="ctr" defTabSz="355600">
+          <a:pPr marL="0" lvl="0" indent="0" algn="ctr" defTabSz="355600">
             <a:lnSpc>
               <a:spcPct val="90000"/>
             </a:lnSpc>
@@ -1849,6 +1754,7 @@
             <a:spcAft>
               <a:spcPct val="35000"/>
             </a:spcAft>
+            <a:buNone/>
           </a:pPr>
           <a:r>
             <a:rPr lang="es-ES" sz="800" b="1" kern="1200" dirty="0">
@@ -1962,7 +1868,7 @@
         </a:bodyPr>
         <a:lstStyle/>
         <a:p>
-          <a:pPr lvl="0" algn="ctr" defTabSz="355600">
+          <a:pPr marL="0" lvl="0" indent="0" algn="ctr" defTabSz="355600">
             <a:lnSpc>
               <a:spcPct val="90000"/>
             </a:lnSpc>
@@ -1972,6 +1878,7 @@
             <a:spcAft>
               <a:spcPct val="35000"/>
             </a:spcAft>
+            <a:buNone/>
           </a:pPr>
           <a:r>
             <a:rPr lang="es-ES" sz="800" b="1" kern="1200" dirty="0">
@@ -2107,7 +2014,7 @@
         </a:bodyPr>
         <a:lstStyle/>
         <a:p>
-          <a:pPr lvl="0" algn="ctr" defTabSz="355600">
+          <a:pPr marL="0" lvl="0" indent="0" algn="ctr" defTabSz="355600">
             <a:lnSpc>
               <a:spcPct val="90000"/>
             </a:lnSpc>
@@ -2117,6 +2024,7 @@
             <a:spcAft>
               <a:spcPct val="35000"/>
             </a:spcAft>
+            <a:buNone/>
           </a:pPr>
           <a:r>
             <a:rPr lang="es-ES" sz="800" b="1" kern="1200" dirty="0">
@@ -2230,7 +2138,7 @@
         </a:bodyPr>
         <a:lstStyle/>
         <a:p>
-          <a:pPr lvl="0" algn="ctr" defTabSz="355600">
+          <a:pPr marL="0" lvl="0" indent="0" algn="ctr" defTabSz="355600">
             <a:lnSpc>
               <a:spcPct val="90000"/>
             </a:lnSpc>
@@ -2240,6 +2148,7 @@
             <a:spcAft>
               <a:spcPct val="35000"/>
             </a:spcAft>
+            <a:buNone/>
           </a:pPr>
           <a:r>
             <a:rPr lang="es-ES" sz="800" b="1" kern="1200" dirty="0">
@@ -2355,7 +2264,7 @@
         </a:bodyPr>
         <a:lstStyle/>
         <a:p>
-          <a:pPr lvl="0" algn="ctr" defTabSz="355600">
+          <a:pPr marL="0" lvl="0" indent="0" algn="ctr" defTabSz="355600">
             <a:lnSpc>
               <a:spcPct val="90000"/>
             </a:lnSpc>
@@ -2365,6 +2274,7 @@
             <a:spcAft>
               <a:spcPct val="35000"/>
             </a:spcAft>
+            <a:buNone/>
           </a:pPr>
           <a:r>
             <a:rPr lang="es-ES" sz="800" b="1" kern="1200" dirty="0">
@@ -2478,7 +2388,7 @@
         </a:bodyPr>
         <a:lstStyle/>
         <a:p>
-          <a:pPr lvl="0" algn="ctr" defTabSz="355600">
+          <a:pPr marL="0" lvl="0" indent="0" algn="ctr" defTabSz="355600">
             <a:lnSpc>
               <a:spcPct val="90000"/>
             </a:lnSpc>
@@ -2488,6 +2398,7 @@
             <a:spcAft>
               <a:spcPct val="35000"/>
             </a:spcAft>
+            <a:buNone/>
           </a:pPr>
           <a:r>
             <a:rPr lang="es-ES" sz="800" b="1" kern="1200" dirty="0">
@@ -2603,7 +2514,7 @@
         </a:bodyPr>
         <a:lstStyle/>
         <a:p>
-          <a:pPr lvl="0" algn="ctr" defTabSz="355600">
+          <a:pPr marL="0" lvl="0" indent="0" algn="ctr" defTabSz="355600">
             <a:lnSpc>
               <a:spcPct val="90000"/>
             </a:lnSpc>
@@ -2613,6 +2524,7 @@
             <a:spcAft>
               <a:spcPct val="35000"/>
             </a:spcAft>
+            <a:buNone/>
           </a:pPr>
           <a:r>
             <a:rPr lang="es-ES" sz="800" b="1" kern="1200" dirty="0">
@@ -2726,7 +2638,7 @@
         </a:bodyPr>
         <a:lstStyle/>
         <a:p>
-          <a:pPr lvl="0" algn="ctr" defTabSz="355600">
+          <a:pPr marL="0" lvl="0" indent="0" algn="ctr" defTabSz="355600">
             <a:lnSpc>
               <a:spcPct val="90000"/>
             </a:lnSpc>
@@ -2736,6 +2648,7 @@
             <a:spcAft>
               <a:spcPct val="35000"/>
             </a:spcAft>
+            <a:buNone/>
           </a:pPr>
           <a:r>
             <a:rPr lang="es-ES" sz="800" b="1" kern="1200" dirty="0">
@@ -2851,7 +2764,7 @@
         </a:bodyPr>
         <a:lstStyle/>
         <a:p>
-          <a:pPr lvl="0" algn="ctr" defTabSz="355600">
+          <a:pPr marL="0" lvl="0" indent="0" algn="ctr" defTabSz="355600">
             <a:lnSpc>
               <a:spcPct val="90000"/>
             </a:lnSpc>
@@ -2861,6 +2774,7 @@
             <a:spcAft>
               <a:spcPct val="35000"/>
             </a:spcAft>
+            <a:buNone/>
           </a:pPr>
           <a:r>
             <a:rPr lang="es-ES" sz="800" b="1" kern="1200" dirty="0">
@@ -2974,7 +2888,7 @@
         </a:bodyPr>
         <a:lstStyle/>
         <a:p>
-          <a:pPr lvl="0" algn="ctr" defTabSz="355600">
+          <a:pPr marL="0" lvl="0" indent="0" algn="ctr" defTabSz="355600">
             <a:lnSpc>
               <a:spcPct val="90000"/>
             </a:lnSpc>
@@ -2984,6 +2898,7 @@
             <a:spcAft>
               <a:spcPct val="35000"/>
             </a:spcAft>
+            <a:buNone/>
           </a:pPr>
           <a:r>
             <a:rPr lang="es-ES" sz="800" b="1" kern="1200" dirty="0">
@@ -4447,7 +4362,7 @@
           <a:p>
             <a:fld id="{F7C2FF9A-23E1-4EAD-A118-A77F41DDE3B1}" type="datetimeFigureOut">
               <a:rPr lang="es-CO" smtClean="0"/>
-              <a:t>24/02/2026</a:t>
+              <a:t>17/10/2026</a:t>
             </a:fld>
             <a:endParaRPr lang="es-CO"/>
           </a:p>
@@ -4647,7 +4562,7 @@
           <a:p>
             <a:fld id="{F7C2FF9A-23E1-4EAD-A118-A77F41DDE3B1}" type="datetimeFigureOut">
               <a:rPr lang="es-CO" smtClean="0"/>
-              <a:t>24/02/2026</a:t>
+              <a:t>17/10/2026</a:t>
             </a:fld>
             <a:endParaRPr lang="es-CO"/>
           </a:p>
@@ -4857,7 +4772,7 @@
           <a:p>
             <a:fld id="{F7C2FF9A-23E1-4EAD-A118-A77F41DDE3B1}" type="datetimeFigureOut">
               <a:rPr lang="es-CO" smtClean="0"/>
-              <a:t>24/02/2026</a:t>
+              <a:t>17/10/2026</a:t>
             </a:fld>
             <a:endParaRPr lang="es-CO"/>
           </a:p>
@@ -5057,7 +4972,7 @@
           <a:p>
             <a:fld id="{F7C2FF9A-23E1-4EAD-A118-A77F41DDE3B1}" type="datetimeFigureOut">
               <a:rPr lang="es-CO" smtClean="0"/>
-              <a:t>24/02/2026</a:t>
+              <a:t>17/10/2026</a:t>
             </a:fld>
             <a:endParaRPr lang="es-CO"/>
           </a:p>
@@ -5333,7 +5248,7 @@
           <a:p>
             <a:fld id="{F7C2FF9A-23E1-4EAD-A118-A77F41DDE3B1}" type="datetimeFigureOut">
               <a:rPr lang="es-CO" smtClean="0"/>
-              <a:t>24/02/2026</a:t>
+              <a:t>17/10/2026</a:t>
             </a:fld>
             <a:endParaRPr lang="es-CO"/>
           </a:p>
@@ -5601,7 +5516,7 @@
           <a:p>
             <a:fld id="{F7C2FF9A-23E1-4EAD-A118-A77F41DDE3B1}" type="datetimeFigureOut">
               <a:rPr lang="es-CO" smtClean="0"/>
-              <a:t>24/02/2026</a:t>
+              <a:t>17/10/2026</a:t>
             </a:fld>
             <a:endParaRPr lang="es-CO"/>
           </a:p>
@@ -6016,7 +5931,7 @@
           <a:p>
             <a:fld id="{F7C2FF9A-23E1-4EAD-A118-A77F41DDE3B1}" type="datetimeFigureOut">
               <a:rPr lang="es-CO" smtClean="0"/>
-              <a:t>24/02/2026</a:t>
+              <a:t>17/10/2026</a:t>
             </a:fld>
             <a:endParaRPr lang="es-CO"/>
           </a:p>
@@ -6158,7 +6073,7 @@
           <a:p>
             <a:fld id="{F7C2FF9A-23E1-4EAD-A118-A77F41DDE3B1}" type="datetimeFigureOut">
               <a:rPr lang="es-CO" smtClean="0"/>
-              <a:t>24/02/2026</a:t>
+              <a:t>17/10/2026</a:t>
             </a:fld>
             <a:endParaRPr lang="es-CO"/>
           </a:p>
@@ -6271,7 +6186,7 @@
           <a:p>
             <a:fld id="{F7C2FF9A-23E1-4EAD-A118-A77F41DDE3B1}" type="datetimeFigureOut">
               <a:rPr lang="es-CO" smtClean="0"/>
-              <a:t>24/02/2026</a:t>
+              <a:t>17/10/2026</a:t>
             </a:fld>
             <a:endParaRPr lang="es-CO"/>
           </a:p>
@@ -6584,7 +6499,7 @@
           <a:p>
             <a:fld id="{F7C2FF9A-23E1-4EAD-A118-A77F41DDE3B1}" type="datetimeFigureOut">
               <a:rPr lang="es-CO" smtClean="0"/>
-              <a:t>24/02/2026</a:t>
+              <a:t>17/10/2026</a:t>
             </a:fld>
             <a:endParaRPr lang="es-CO"/>
           </a:p>
@@ -6873,7 +6788,7 @@
           <a:p>
             <a:fld id="{F7C2FF9A-23E1-4EAD-A118-A77F41DDE3B1}" type="datetimeFigureOut">
               <a:rPr lang="es-CO" smtClean="0"/>
-              <a:t>24/02/2026</a:t>
+              <a:t>17/10/2026</a:t>
             </a:fld>
             <a:endParaRPr lang="es-CO"/>
           </a:p>
@@ -7116,7 +7031,7 @@
           <a:p>
             <a:fld id="{F7C2FF9A-23E1-4EAD-A118-A77F41DDE3B1}" type="datetimeFigureOut">
               <a:rPr lang="es-CO" smtClean="0"/>
-              <a:t>24/02/2026</a:t>
+              <a:t>17/10/2026</a:t>
             </a:fld>
             <a:endParaRPr lang="es-CO"/>
           </a:p>
@@ -9459,7 +9374,7 @@
         <p:spPr>
           <a:xfrm>
             <a:off x="427354" y="1460208"/>
-            <a:ext cx="4471039" cy="5808513"/>
+            <a:ext cx="6738556" cy="3743076"/>
           </a:xfrm>
           <a:prstGeom prst="rect">
             <a:avLst/>
@@ -9484,105 +9399,203 @@
               </a:spcAft>
             </a:pPr>
             <a:r>
-              <a:rPr sz="1350" b="1" i="0">
+              <a:rPr sz="1600" b="1" i="0" dirty="0">
                 <a:solidFill>
                   <a:srgbClr val="00B050"/>
                 </a:solidFill>
                 <a:latin typeface="Josefin Sans"/>
               </a:rPr>
-              <a:t>¿Sabían que en Colombia más del 33% de los estudiantes técnicos y tecnológicos desertan antes de graduarse? (SPADIES / MEN)</a:t>
-            </a:r>
-          </a:p>
-          <a:p>
-            <a:pPr>
-              <a:lnSpc>
-                <a:spcPct val="105000"/>
-              </a:lnSpc>
-              <a:spcBef>
-                <a:spcPts val="100"/>
-              </a:spcBef>
-              <a:spcAft>
-                <a:spcPts val="400"/>
-              </a:spcAft>
-            </a:pPr>
-            <a:r>
-              <a:rPr sz="1300" b="1" i="0">
-                <a:solidFill>
-                  <a:srgbClr val="323232"/>
-                </a:solidFill>
-                <a:latin typeface="Josefin Sans"/>
-              </a:rPr>
-              <a:t>Los 3 Dolores Críticos Identificados:</a:t>
-            </a:r>
-          </a:p>
-          <a:p>
-            <a:pPr>
-              <a:lnSpc>
-                <a:spcPct val="105000"/>
-              </a:lnSpc>
-              <a:spcBef>
-                <a:spcPts val="100"/>
-              </a:spcBef>
-              <a:spcAft>
-                <a:spcPts val="300"/>
-              </a:spcAft>
-            </a:pPr>
-            <a:r>
-              <a:rPr sz="1200" b="0" i="0">
-                <a:solidFill>
-                  <a:srgbClr val="323232"/>
-                </a:solidFill>
-                <a:latin typeface="Josefin Sans"/>
-              </a:rPr>
-              <a:t>1. Deserción Silenciosa: Los factores de riesgo académico y socioeconómico se detectan cuando el estudiante ya abandonó el aula.</a:t>
-            </a:r>
-          </a:p>
-          <a:p>
-            <a:pPr>
-              <a:lnSpc>
-                <a:spcPct val="105000"/>
-              </a:lnSpc>
-              <a:spcBef>
-                <a:spcPts val="100"/>
-              </a:spcBef>
-              <a:spcAft>
-                <a:spcPts val="300"/>
-              </a:spcAft>
-            </a:pPr>
-            <a:r>
-              <a:rPr sz="1200" b="0" i="0">
-                <a:solidFill>
-                  <a:srgbClr val="323232"/>
-                </a:solidFill>
-                <a:latin typeface="Josefin Sans"/>
-              </a:rPr>
-              <a:t>2. Brecha de Empleabilidad ('Job Readiness'): Los egresados carecen de entrenamiento real para superar entrevistas técnicas y blandas.</a:t>
-            </a:r>
-          </a:p>
-          <a:p>
-            <a:pPr>
-              <a:lnSpc>
-                <a:spcPct val="105000"/>
-              </a:lnSpc>
-              <a:spcBef>
-                <a:spcPts val="100"/>
-              </a:spcBef>
-              <a:spcAft>
-                <a:spcPts val="400"/>
-              </a:spcAft>
-            </a:pPr>
-            <a:r>
-              <a:rPr sz="1200" b="0" i="0">
-                <a:solidFill>
-                  <a:srgbClr val="323232"/>
-                </a:solidFill>
-                <a:latin typeface="Josefin Sans"/>
-              </a:rPr>
-              <a:t>3. Desconexión con Egresados: La experiencia y capital social de los graduados se encuentra desarticulado y desaprovechado.</a:t>
-            </a:r>
-          </a:p>
-          <a:p>
-            <a:pPr>
+              <a:t>¿</a:t>
+            </a:r>
+            <a:r>
+              <a:rPr sz="1600" b="1" i="0" dirty="0" err="1">
+                <a:solidFill>
+                  <a:srgbClr val="00B050"/>
+                </a:solidFill>
+                <a:latin typeface="Josefin Sans"/>
+              </a:rPr>
+              <a:t>Sabían</a:t>
+            </a:r>
+            <a:r>
+              <a:rPr sz="1600" b="1" i="0" dirty="0">
+                <a:solidFill>
+                  <a:srgbClr val="00B050"/>
+                </a:solidFill>
+                <a:latin typeface="Josefin Sans"/>
+              </a:rPr>
+              <a:t> </a:t>
+            </a:r>
+            <a:r>
+              <a:rPr sz="1600" b="1" i="0" dirty="0" err="1">
+                <a:solidFill>
+                  <a:srgbClr val="00B050"/>
+                </a:solidFill>
+                <a:latin typeface="Josefin Sans"/>
+              </a:rPr>
+              <a:t>que</a:t>
+            </a:r>
+            <a:r>
+              <a:rPr sz="1600" b="1" i="0" dirty="0">
+                <a:solidFill>
+                  <a:srgbClr val="00B050"/>
+                </a:solidFill>
+                <a:latin typeface="Josefin Sans"/>
+              </a:rPr>
+              <a:t> </a:t>
+            </a:r>
+            <a:r>
+              <a:rPr sz="1600" b="1" i="0" dirty="0" err="1">
+                <a:solidFill>
+                  <a:srgbClr val="00B050"/>
+                </a:solidFill>
+                <a:latin typeface="Josefin Sans"/>
+              </a:rPr>
+              <a:t>en</a:t>
+            </a:r>
+            <a:r>
+              <a:rPr sz="1600" b="1" i="0" dirty="0">
+                <a:solidFill>
+                  <a:srgbClr val="00B050"/>
+                </a:solidFill>
+                <a:latin typeface="Josefin Sans"/>
+              </a:rPr>
+              <a:t> Colombia </a:t>
+            </a:r>
+            <a:r>
+              <a:rPr sz="1600" b="1" i="0" dirty="0" err="1">
+                <a:solidFill>
+                  <a:srgbClr val="00B050"/>
+                </a:solidFill>
+                <a:latin typeface="Josefin Sans"/>
+              </a:rPr>
+              <a:t>más</a:t>
+            </a:r>
+            <a:r>
+              <a:rPr sz="1600" b="1" i="0" dirty="0">
+                <a:solidFill>
+                  <a:srgbClr val="00B050"/>
+                </a:solidFill>
+                <a:latin typeface="Josefin Sans"/>
+              </a:rPr>
+              <a:t> del 33% de </a:t>
+            </a:r>
+            <a:r>
+              <a:rPr sz="1600" b="1" i="0" dirty="0" err="1">
+                <a:solidFill>
+                  <a:srgbClr val="00B050"/>
+                </a:solidFill>
+                <a:latin typeface="Josefin Sans"/>
+              </a:rPr>
+              <a:t>los</a:t>
+            </a:r>
+            <a:r>
+              <a:rPr sz="1600" b="1" i="0" dirty="0">
+                <a:solidFill>
+                  <a:srgbClr val="00B050"/>
+                </a:solidFill>
+                <a:latin typeface="Josefin Sans"/>
+              </a:rPr>
+              <a:t> </a:t>
+            </a:r>
+            <a:r>
+              <a:rPr sz="1600" b="1" i="0" dirty="0" err="1">
+                <a:solidFill>
+                  <a:srgbClr val="00B050"/>
+                </a:solidFill>
+                <a:latin typeface="Josefin Sans"/>
+              </a:rPr>
+              <a:t>estudiantes</a:t>
+            </a:r>
+            <a:r>
+              <a:rPr sz="1600" b="1" i="0" dirty="0">
+                <a:solidFill>
+                  <a:srgbClr val="00B050"/>
+                </a:solidFill>
+                <a:latin typeface="Josefin Sans"/>
+              </a:rPr>
+              <a:t> </a:t>
+            </a:r>
+            <a:r>
+              <a:rPr sz="1600" b="1" i="0" dirty="0" err="1">
+                <a:solidFill>
+                  <a:srgbClr val="00B050"/>
+                </a:solidFill>
+                <a:latin typeface="Josefin Sans"/>
+              </a:rPr>
+              <a:t>técnicos</a:t>
+            </a:r>
+            <a:r>
+              <a:rPr sz="1600" b="1" i="0" dirty="0">
+                <a:solidFill>
+                  <a:srgbClr val="00B050"/>
+                </a:solidFill>
+                <a:latin typeface="Josefin Sans"/>
+              </a:rPr>
+              <a:t> y </a:t>
+            </a:r>
+            <a:r>
+              <a:rPr sz="1600" b="1" i="0" dirty="0" err="1">
+                <a:solidFill>
+                  <a:srgbClr val="00B050"/>
+                </a:solidFill>
+                <a:latin typeface="Josefin Sans"/>
+              </a:rPr>
+              <a:t>tecnológicos</a:t>
+            </a:r>
+            <a:r>
+              <a:rPr sz="1600" b="1" i="0" dirty="0">
+                <a:solidFill>
+                  <a:srgbClr val="00B050"/>
+                </a:solidFill>
+                <a:latin typeface="Josefin Sans"/>
+              </a:rPr>
+              <a:t> </a:t>
+            </a:r>
+            <a:r>
+              <a:rPr sz="1600" b="1" i="0" dirty="0" err="1">
+                <a:solidFill>
+                  <a:srgbClr val="00B050"/>
+                </a:solidFill>
+                <a:latin typeface="Josefin Sans"/>
+              </a:rPr>
+              <a:t>desertan</a:t>
+            </a:r>
+            <a:r>
+              <a:rPr sz="1600" b="1" i="0" dirty="0">
+                <a:solidFill>
+                  <a:srgbClr val="00B050"/>
+                </a:solidFill>
+                <a:latin typeface="Josefin Sans"/>
+              </a:rPr>
+              <a:t> antes de </a:t>
+            </a:r>
+            <a:r>
+              <a:rPr sz="1600" b="1" i="0" dirty="0" err="1">
+                <a:solidFill>
+                  <a:srgbClr val="00B050"/>
+                </a:solidFill>
+                <a:latin typeface="Josefin Sans"/>
+              </a:rPr>
+              <a:t>graduarse</a:t>
+            </a:r>
+            <a:r>
+              <a:rPr sz="1600" b="1" i="0" dirty="0">
+                <a:solidFill>
+                  <a:srgbClr val="00B050"/>
+                </a:solidFill>
+                <a:latin typeface="Josefin Sans"/>
+              </a:rPr>
+              <a:t>? </a:t>
+            </a:r>
+            <a:endParaRPr lang="es-CO" sz="1600" b="1" dirty="0">
+              <a:solidFill>
+                <a:srgbClr val="00B050"/>
+              </a:solidFill>
+              <a:latin typeface="Josefin Sans"/>
+            </a:endParaRPr>
+          </a:p>
+          <a:p>
+            <a:pPr lvl="1" algn="just">
               <a:lnSpc>
                 <a:spcPct val="105000"/>
               </a:lnSpc>
@@ -9593,36 +9606,83 @@
                 <a:spcPts val="600"/>
               </a:spcAft>
             </a:pPr>
-            <a:r>
-              <a:rPr sz="1200" b="0" i="0">
-                <a:solidFill>
-                  <a:srgbClr val="323232"/>
-                </a:solidFill>
-                <a:latin typeface="Josefin Sans"/>
-              </a:rPr>
-              <a:t>• Alternativas Actuales: Plataformas LMS (Moodle, Q10) meramente administrativas, sin analítica predictiva ni simuladores adaptados.</a:t>
-            </a:r>
-          </a:p>
-          <a:p>
-            <a:pPr>
-              <a:lnSpc>
-                <a:spcPct val="105000"/>
-              </a:lnSpc>
-              <a:spcBef>
-                <a:spcPts val="100"/>
-              </a:spcBef>
-              <a:spcAft>
-                <a:spcPts val="0"/>
-              </a:spcAft>
-            </a:pPr>
-            <a:r>
-              <a:rPr sz="1100" b="0" i="1">
-                <a:solidFill>
-                  <a:srgbClr val="787878"/>
-                </a:solidFill>
-                <a:latin typeface="Josefin Sans"/>
-              </a:rPr>
-              <a:t>(Tiempo sugerido: 1 minuto)</a:t>
+            <a:endParaRPr lang="es-CO" sz="1600" dirty="0"/>
+          </a:p>
+          <a:p>
+            <a:r>
+              <a:rPr lang="es-CO" sz="1600" dirty="0"/>
+              <a:t>• </a:t>
+            </a:r>
+            <a:r>
+              <a:rPr lang="es-CO" sz="1600" b="1" dirty="0"/>
+              <a:t>Deserción Silenciosa:</a:t>
+            </a:r>
+            <a:r>
+              <a:rPr lang="es-CO" sz="1600" dirty="0"/>
+              <a:t> Detección tardía; las alertas llegan cuando el estudiante ya abandonó el aula</a:t>
+            </a:r>
+          </a:p>
+          <a:p>
+            <a:br>
+              <a:rPr lang="es-CO" sz="1600" dirty="0"/>
+            </a:br>
+            <a:r>
+              <a:rPr lang="es-CO" sz="1600" dirty="0"/>
+              <a:t>• </a:t>
+            </a:r>
+            <a:r>
+              <a:rPr lang="es-CO" sz="1600" b="1" dirty="0"/>
+              <a:t>Brecha de Empleabilidad (</a:t>
+            </a:r>
+            <a:r>
+              <a:rPr lang="es-CO" sz="1600" b="1" i="1" dirty="0"/>
+              <a:t>Job </a:t>
+            </a:r>
+            <a:r>
+              <a:rPr lang="es-CO" sz="1600" b="1" i="1" dirty="0" err="1"/>
+              <a:t>Readiness</a:t>
+            </a:r>
+            <a:r>
+              <a:rPr lang="es-CO" sz="1600" b="1" dirty="0"/>
+              <a:t>):</a:t>
+            </a:r>
+            <a:r>
+              <a:rPr lang="es-CO" sz="1600" dirty="0"/>
+              <a:t> Inseguridad y falta de preparación práctica para entrevistas técnicas y habilidades blandas</a:t>
+            </a:r>
+          </a:p>
+          <a:p>
+            <a:br>
+              <a:rPr lang="es-CO" sz="1600" dirty="0"/>
+            </a:br>
+            <a:r>
+              <a:rPr lang="es-CO" sz="1600" dirty="0"/>
+              <a:t>• </a:t>
+            </a:r>
+            <a:r>
+              <a:rPr lang="es-CO" sz="1600" b="1" dirty="0"/>
+              <a:t>Desconexión con Egresados:</a:t>
+            </a:r>
+            <a:r>
+              <a:rPr lang="es-CO" sz="1600" dirty="0"/>
+              <a:t> El capital social y la experiencia de los graduados están desarticulados y desaprovechados</a:t>
+            </a:r>
+          </a:p>
+          <a:p>
+            <a:br>
+              <a:rPr lang="es-CO" sz="1600" dirty="0"/>
+            </a:br>
+            <a:r>
+              <a:rPr lang="es-CO" sz="1600" dirty="0"/>
+              <a:t>• </a:t>
+            </a:r>
+            <a:r>
+              <a:rPr lang="es-CO" sz="1600" b="1" dirty="0"/>
+              <a:t>Limitación Actual:</a:t>
+            </a:r>
+            <a:r>
+              <a:rPr lang="es-CO" sz="1600" dirty="0"/>
+              <a:t> Los sistemas LMS tradicionales (Moodle, Q10) son meramente reactivos y de registro de notas, sin analítica predictiva</a:t>
             </a:r>
           </a:p>
         </p:txBody>
@@ -9767,7 +9827,7 @@
         <p:spPr>
           <a:xfrm>
             <a:off x="427354" y="1460208"/>
-            <a:ext cx="4471039" cy="4063485"/>
+            <a:ext cx="4745147" cy="3500767"/>
           </a:xfrm>
           <a:prstGeom prst="rect">
             <a:avLst/>
@@ -9792,13 +9852,67 @@
               </a:spcAft>
             </a:pPr>
             <a:r>
-              <a:rPr sz="1400" b="1" i="0">
+              <a:rPr sz="1400" b="1" i="0" dirty="0">
                 <a:solidFill>
                   <a:srgbClr val="00B050"/>
                 </a:solidFill>
                 <a:latin typeface="Josefin Sans"/>
               </a:rPr>
-              <a:t>El Protagonista: Directores de Bienestar y Rectores</a:t>
+              <a:t>El </a:t>
+            </a:r>
+            <a:r>
+              <a:rPr sz="1400" b="1" i="0" dirty="0" err="1">
+                <a:solidFill>
+                  <a:srgbClr val="00B050"/>
+                </a:solidFill>
+                <a:latin typeface="Josefin Sans"/>
+              </a:rPr>
+              <a:t>Protagonista</a:t>
+            </a:r>
+            <a:r>
+              <a:rPr sz="1400" b="1" i="0" dirty="0">
+                <a:solidFill>
+                  <a:srgbClr val="00B050"/>
+                </a:solidFill>
+                <a:latin typeface="Josefin Sans"/>
+              </a:rPr>
+              <a:t>: </a:t>
+            </a:r>
+            <a:r>
+              <a:rPr sz="1400" b="1" i="0" dirty="0" err="1">
+                <a:solidFill>
+                  <a:srgbClr val="00B050"/>
+                </a:solidFill>
+                <a:latin typeface="Josefin Sans"/>
+              </a:rPr>
+              <a:t>Directores</a:t>
+            </a:r>
+            <a:r>
+              <a:rPr sz="1400" b="1" i="0" dirty="0">
+                <a:solidFill>
+                  <a:srgbClr val="00B050"/>
+                </a:solidFill>
+                <a:latin typeface="Josefin Sans"/>
+              </a:rPr>
+              <a:t> de </a:t>
+            </a:r>
+            <a:r>
+              <a:rPr sz="1400" b="1" i="0" dirty="0" err="1">
+                <a:solidFill>
+                  <a:srgbClr val="00B050"/>
+                </a:solidFill>
+                <a:latin typeface="Josefin Sans"/>
+              </a:rPr>
+              <a:t>Bienestar</a:t>
+            </a:r>
+            <a:r>
+              <a:rPr sz="1400" b="1" i="0" dirty="0">
+                <a:solidFill>
+                  <a:srgbClr val="00B050"/>
+                </a:solidFill>
+                <a:latin typeface="Josefin Sans"/>
+              </a:rPr>
+              <a:t> y Rectores</a:t>
             </a:r>
           </a:p>
           <a:p>
@@ -9814,13 +9928,175 @@
               </a:spcAft>
             </a:pPr>
             <a:r>
-              <a:rPr sz="1200" b="0" i="0">
-                <a:solidFill>
-                  <a:srgbClr val="323232"/>
-                </a:solidFill>
-                <a:latin typeface="Josefin Sans"/>
-              </a:rPr>
-              <a:t>• Cliente B2B (Decisor de Compra): Instituciones privadas de educación técnica, tecnológica e IES intermedias en Colombia.</a:t>
+              <a:rPr sz="1200" b="0" i="0" dirty="0">
+                <a:solidFill>
+                  <a:srgbClr val="323232"/>
+                </a:solidFill>
+                <a:latin typeface="Josefin Sans"/>
+              </a:rPr>
+              <a:t>• </a:t>
+            </a:r>
+            <a:r>
+              <a:rPr sz="1200" b="0" i="0" dirty="0" err="1">
+                <a:solidFill>
+                  <a:srgbClr val="323232"/>
+                </a:solidFill>
+                <a:latin typeface="Josefin Sans"/>
+              </a:rPr>
+              <a:t>Cliente</a:t>
+            </a:r>
+            <a:r>
+              <a:rPr sz="1200" b="0" i="0" dirty="0">
+                <a:solidFill>
+                  <a:srgbClr val="323232"/>
+                </a:solidFill>
+                <a:latin typeface="Josefin Sans"/>
+              </a:rPr>
+              <a:t> B2B (</a:t>
+            </a:r>
+            <a:r>
+              <a:rPr sz="1200" b="0" i="0" dirty="0" err="1">
+                <a:solidFill>
+                  <a:srgbClr val="323232"/>
+                </a:solidFill>
+                <a:latin typeface="Josefin Sans"/>
+              </a:rPr>
+              <a:t>Decisor</a:t>
+            </a:r>
+            <a:r>
+              <a:rPr sz="1200" b="0" i="0" dirty="0">
+                <a:solidFill>
+                  <a:srgbClr val="323232"/>
+                </a:solidFill>
+                <a:latin typeface="Josefin Sans"/>
+              </a:rPr>
+              <a:t> de Compra): </a:t>
+            </a:r>
+            <a:r>
+              <a:rPr sz="1200" b="0" i="0" dirty="0" err="1">
+                <a:solidFill>
+                  <a:srgbClr val="323232"/>
+                </a:solidFill>
+                <a:latin typeface="Josefin Sans"/>
+              </a:rPr>
+              <a:t>Instituciones</a:t>
+            </a:r>
+            <a:r>
+              <a:rPr sz="1200" b="0" i="0" dirty="0">
+                <a:solidFill>
+                  <a:srgbClr val="323232"/>
+                </a:solidFill>
+                <a:latin typeface="Josefin Sans"/>
+              </a:rPr>
+              <a:t> </a:t>
+            </a:r>
+            <a:r>
+              <a:rPr sz="1200" b="0" i="0" dirty="0" err="1">
+                <a:solidFill>
+                  <a:srgbClr val="323232"/>
+                </a:solidFill>
+                <a:latin typeface="Josefin Sans"/>
+              </a:rPr>
+              <a:t>privadas</a:t>
+            </a:r>
+            <a:r>
+              <a:rPr sz="1200" b="0" i="0" dirty="0">
+                <a:solidFill>
+                  <a:srgbClr val="323232"/>
+                </a:solidFill>
+                <a:latin typeface="Josefin Sans"/>
+              </a:rPr>
+              <a:t> de </a:t>
+            </a:r>
+            <a:r>
+              <a:rPr sz="1200" b="0" i="0" dirty="0" err="1">
+                <a:solidFill>
+                  <a:srgbClr val="323232"/>
+                </a:solidFill>
+                <a:latin typeface="Josefin Sans"/>
+              </a:rPr>
+              <a:t>educación</a:t>
+            </a:r>
+            <a:r>
+              <a:rPr sz="1200" b="0" i="0" dirty="0">
+                <a:solidFill>
+                  <a:srgbClr val="323232"/>
+                </a:solidFill>
+                <a:latin typeface="Josefin Sans"/>
+              </a:rPr>
+              <a:t> </a:t>
+            </a:r>
+            <a:r>
+              <a:rPr sz="1200" b="0" i="0" dirty="0" err="1">
+                <a:solidFill>
+                  <a:srgbClr val="323232"/>
+                </a:solidFill>
+                <a:latin typeface="Josefin Sans"/>
+              </a:rPr>
+              <a:t>técnica</a:t>
+            </a:r>
+            <a:r>
+              <a:rPr sz="1200" b="0" i="0" dirty="0">
+                <a:solidFill>
+                  <a:srgbClr val="323232"/>
+                </a:solidFill>
+                <a:latin typeface="Josefin Sans"/>
+              </a:rPr>
+              <a:t>, </a:t>
+            </a:r>
+            <a:r>
+              <a:rPr sz="1200" b="0" i="0" dirty="0" err="1">
+                <a:solidFill>
+                  <a:srgbClr val="323232"/>
+                </a:solidFill>
+                <a:latin typeface="Josefin Sans"/>
+              </a:rPr>
+              <a:t>tecnológica</a:t>
+            </a:r>
+            <a:r>
+              <a:rPr sz="1200" b="0" i="0" dirty="0">
+                <a:solidFill>
+                  <a:srgbClr val="323232"/>
+                </a:solidFill>
+                <a:latin typeface="Josefin Sans"/>
+              </a:rPr>
+              <a:t> e IES </a:t>
+            </a:r>
+            <a:r>
+              <a:rPr sz="1200" b="0" i="0" dirty="0" err="1">
+                <a:solidFill>
+                  <a:srgbClr val="323232"/>
+                </a:solidFill>
+                <a:latin typeface="Josefin Sans"/>
+              </a:rPr>
+              <a:t>intermedias</a:t>
+            </a:r>
+            <a:r>
+              <a:rPr sz="1200" b="0" i="0" dirty="0">
+                <a:solidFill>
+                  <a:srgbClr val="323232"/>
+                </a:solidFill>
+                <a:latin typeface="Josefin Sans"/>
+              </a:rPr>
+              <a:t> </a:t>
+            </a:r>
+            <a:r>
+              <a:rPr sz="1200" b="0" i="0" dirty="0" err="1">
+                <a:solidFill>
+                  <a:srgbClr val="323232"/>
+                </a:solidFill>
+                <a:latin typeface="Josefin Sans"/>
+              </a:rPr>
+              <a:t>en</a:t>
+            </a:r>
+            <a:r>
+              <a:rPr sz="1200" b="0" i="0" dirty="0">
+                <a:solidFill>
+                  <a:srgbClr val="323232"/>
+                </a:solidFill>
+                <a:latin typeface="Josefin Sans"/>
+              </a:rPr>
+              <a:t> Colombia.</a:t>
             </a:r>
           </a:p>
           <a:p>
@@ -9836,13 +10112,247 @@
               </a:spcAft>
             </a:pPr>
             <a:r>
-              <a:rPr sz="1200" b="0" i="0">
-                <a:solidFill>
-                  <a:srgbClr val="323232"/>
-                </a:solidFill>
-                <a:latin typeface="Josefin Sans"/>
-              </a:rPr>
-              <a:t>• La Necesidad del Cliente: Evitar pérdidas millonarias en matrículas ($3M a $6M COP por alumno desertado) y asegurar la acreditación de calidad ante el MEN.</a:t>
+              <a:rPr sz="1200" b="0" i="0" dirty="0">
+                <a:solidFill>
+                  <a:srgbClr val="323232"/>
+                </a:solidFill>
+                <a:latin typeface="Josefin Sans"/>
+              </a:rPr>
+              <a:t>• La </a:t>
+            </a:r>
+            <a:r>
+              <a:rPr sz="1200" b="0" i="0" dirty="0" err="1">
+                <a:solidFill>
+                  <a:srgbClr val="323232"/>
+                </a:solidFill>
+                <a:latin typeface="Josefin Sans"/>
+              </a:rPr>
+              <a:t>Necesidad</a:t>
+            </a:r>
+            <a:r>
+              <a:rPr sz="1200" b="0" i="0" dirty="0">
+                <a:solidFill>
+                  <a:srgbClr val="323232"/>
+                </a:solidFill>
+                <a:latin typeface="Josefin Sans"/>
+              </a:rPr>
+              <a:t> del </a:t>
+            </a:r>
+            <a:r>
+              <a:rPr sz="1200" b="0" i="0" dirty="0" err="1">
+                <a:solidFill>
+                  <a:srgbClr val="323232"/>
+                </a:solidFill>
+                <a:latin typeface="Josefin Sans"/>
+              </a:rPr>
+              <a:t>Cliente</a:t>
+            </a:r>
+            <a:r>
+              <a:rPr sz="1200" b="0" i="0" dirty="0">
+                <a:solidFill>
+                  <a:srgbClr val="323232"/>
+                </a:solidFill>
+                <a:latin typeface="Josefin Sans"/>
+              </a:rPr>
+              <a:t>: </a:t>
+            </a:r>
+            <a:r>
+              <a:rPr sz="1200" b="0" i="0" dirty="0" err="1">
+                <a:solidFill>
+                  <a:srgbClr val="323232"/>
+                </a:solidFill>
+                <a:latin typeface="Josefin Sans"/>
+              </a:rPr>
+              <a:t>Evitar</a:t>
+            </a:r>
+            <a:r>
+              <a:rPr sz="1200" b="0" i="0" dirty="0">
+                <a:solidFill>
+                  <a:srgbClr val="323232"/>
+                </a:solidFill>
+                <a:latin typeface="Josefin Sans"/>
+              </a:rPr>
+              <a:t> </a:t>
+            </a:r>
+            <a:r>
+              <a:rPr sz="1200" b="0" i="0" dirty="0" err="1">
+                <a:solidFill>
+                  <a:srgbClr val="323232"/>
+                </a:solidFill>
+                <a:latin typeface="Josefin Sans"/>
+              </a:rPr>
+              <a:t>pérdidas</a:t>
+            </a:r>
+            <a:r>
+              <a:rPr sz="1200" b="0" i="0" dirty="0">
+                <a:solidFill>
+                  <a:srgbClr val="323232"/>
+                </a:solidFill>
+                <a:latin typeface="Josefin Sans"/>
+              </a:rPr>
+              <a:t> </a:t>
+            </a:r>
+            <a:r>
+              <a:rPr sz="1200" b="0" i="0" dirty="0" err="1">
+                <a:solidFill>
+                  <a:srgbClr val="323232"/>
+                </a:solidFill>
+                <a:latin typeface="Josefin Sans"/>
+              </a:rPr>
+              <a:t>millonarias</a:t>
+            </a:r>
+            <a:r>
+              <a:rPr sz="1200" b="0" i="0" dirty="0">
+                <a:solidFill>
+                  <a:srgbClr val="323232"/>
+                </a:solidFill>
+                <a:latin typeface="Josefin Sans"/>
+              </a:rPr>
+              <a:t> </a:t>
+            </a:r>
+            <a:r>
+              <a:rPr sz="1200" b="0" i="0" dirty="0" err="1">
+                <a:solidFill>
+                  <a:srgbClr val="323232"/>
+                </a:solidFill>
+                <a:latin typeface="Josefin Sans"/>
+              </a:rPr>
+              <a:t>en</a:t>
+            </a:r>
+            <a:r>
+              <a:rPr sz="1200" b="0" i="0" dirty="0">
+                <a:solidFill>
+                  <a:srgbClr val="323232"/>
+                </a:solidFill>
+                <a:latin typeface="Josefin Sans"/>
+              </a:rPr>
+              <a:t> </a:t>
+            </a:r>
+            <a:r>
+              <a:rPr sz="1200" b="0" i="0" dirty="0" err="1">
+                <a:solidFill>
+                  <a:srgbClr val="323232"/>
+                </a:solidFill>
+                <a:latin typeface="Josefin Sans"/>
+              </a:rPr>
+              <a:t>matrículas</a:t>
+            </a:r>
+            <a:r>
+              <a:rPr sz="1200" b="0" i="0" dirty="0">
+                <a:solidFill>
+                  <a:srgbClr val="323232"/>
+                </a:solidFill>
+                <a:latin typeface="Josefin Sans"/>
+              </a:rPr>
+              <a:t> ($3M a $6M COP </a:t>
+            </a:r>
+            <a:r>
+              <a:rPr sz="1200" b="0" i="0" dirty="0" err="1">
+                <a:solidFill>
+                  <a:srgbClr val="323232"/>
+                </a:solidFill>
+                <a:latin typeface="Josefin Sans"/>
+              </a:rPr>
+              <a:t>por</a:t>
+            </a:r>
+            <a:r>
+              <a:rPr sz="1200" b="0" i="0" dirty="0">
+                <a:solidFill>
+                  <a:srgbClr val="323232"/>
+                </a:solidFill>
+                <a:latin typeface="Josefin Sans"/>
+              </a:rPr>
+              <a:t> </a:t>
+            </a:r>
+            <a:r>
+              <a:rPr sz="1200" b="0" i="0" dirty="0" err="1">
+                <a:solidFill>
+                  <a:srgbClr val="323232"/>
+                </a:solidFill>
+                <a:latin typeface="Josefin Sans"/>
+              </a:rPr>
+              <a:t>alumno</a:t>
+            </a:r>
+            <a:r>
+              <a:rPr sz="1200" b="0" i="0" dirty="0">
+                <a:solidFill>
+                  <a:srgbClr val="323232"/>
+                </a:solidFill>
+                <a:latin typeface="Josefin Sans"/>
+              </a:rPr>
+              <a:t> </a:t>
+            </a:r>
+            <a:r>
+              <a:rPr sz="1200" b="0" i="0" dirty="0" err="1">
+                <a:solidFill>
+                  <a:srgbClr val="323232"/>
+                </a:solidFill>
+                <a:latin typeface="Josefin Sans"/>
+              </a:rPr>
+              <a:t>desertado</a:t>
+            </a:r>
+            <a:r>
+              <a:rPr sz="1200" b="0" i="0" dirty="0">
+                <a:solidFill>
+                  <a:srgbClr val="323232"/>
+                </a:solidFill>
+                <a:latin typeface="Josefin Sans"/>
+              </a:rPr>
+              <a:t>) y </a:t>
+            </a:r>
+            <a:r>
+              <a:rPr sz="1200" b="0" i="0" dirty="0" err="1">
+                <a:solidFill>
+                  <a:srgbClr val="323232"/>
+                </a:solidFill>
+                <a:latin typeface="Josefin Sans"/>
+              </a:rPr>
+              <a:t>asegurar</a:t>
+            </a:r>
+            <a:r>
+              <a:rPr sz="1200" b="0" i="0" dirty="0">
+                <a:solidFill>
+                  <a:srgbClr val="323232"/>
+                </a:solidFill>
+                <a:latin typeface="Josefin Sans"/>
+              </a:rPr>
+              <a:t> la </a:t>
+            </a:r>
+            <a:r>
+              <a:rPr sz="1200" b="0" i="0" dirty="0" err="1">
+                <a:solidFill>
+                  <a:srgbClr val="323232"/>
+                </a:solidFill>
+                <a:latin typeface="Josefin Sans"/>
+              </a:rPr>
+              <a:t>acreditación</a:t>
+            </a:r>
+            <a:r>
+              <a:rPr sz="1200" b="0" i="0" dirty="0">
+                <a:solidFill>
+                  <a:srgbClr val="323232"/>
+                </a:solidFill>
+                <a:latin typeface="Josefin Sans"/>
+              </a:rPr>
+              <a:t> de </a:t>
+            </a:r>
+            <a:r>
+              <a:rPr sz="1200" b="0" i="0" dirty="0" err="1">
+                <a:solidFill>
+                  <a:srgbClr val="323232"/>
+                </a:solidFill>
+                <a:latin typeface="Josefin Sans"/>
+              </a:rPr>
+              <a:t>calidad</a:t>
+            </a:r>
+            <a:r>
+              <a:rPr sz="1200" b="0" i="0" dirty="0">
+                <a:solidFill>
+                  <a:srgbClr val="323232"/>
+                </a:solidFill>
+                <a:latin typeface="Josefin Sans"/>
+              </a:rPr>
+              <a:t> ante el MEN.</a:t>
             </a:r>
           </a:p>
           <a:p>
@@ -9858,13 +10368,40 @@
               </a:spcAft>
             </a:pPr>
             <a:r>
-              <a:rPr sz="1300" b="1" i="0">
-                <a:solidFill>
-                  <a:srgbClr val="323232"/>
-                </a:solidFill>
-                <a:latin typeface="Josefin Sans"/>
-              </a:rPr>
-              <a:t>Usuarios Finales y Beneficiarios (B2C):</a:t>
+              <a:rPr sz="1300" b="1" i="0" dirty="0" err="1">
+                <a:solidFill>
+                  <a:srgbClr val="323232"/>
+                </a:solidFill>
+                <a:latin typeface="Josefin Sans"/>
+              </a:rPr>
+              <a:t>Usuarios</a:t>
+            </a:r>
+            <a:r>
+              <a:rPr sz="1300" b="1" i="0" dirty="0">
+                <a:solidFill>
+                  <a:srgbClr val="323232"/>
+                </a:solidFill>
+                <a:latin typeface="Josefin Sans"/>
+              </a:rPr>
+              <a:t> Finales y </a:t>
+            </a:r>
+            <a:r>
+              <a:rPr sz="1300" b="1" i="0" dirty="0" err="1">
+                <a:solidFill>
+                  <a:srgbClr val="323232"/>
+                </a:solidFill>
+                <a:latin typeface="Josefin Sans"/>
+              </a:rPr>
+              <a:t>Beneficiarios</a:t>
+            </a:r>
+            <a:r>
+              <a:rPr sz="1300" b="1" i="0" dirty="0">
+                <a:solidFill>
+                  <a:srgbClr val="323232"/>
+                </a:solidFill>
+                <a:latin typeface="Josefin Sans"/>
+              </a:rPr>
+              <a:t> (B2C):</a:t>
             </a:r>
           </a:p>
           <a:p>
@@ -9880,13 +10417,211 @@
               </a:spcAft>
             </a:pPr>
             <a:r>
-              <a:rPr sz="1200" b="0" i="0">
-                <a:solidFill>
-                  <a:srgbClr val="323232"/>
-                </a:solidFill>
-                <a:latin typeface="Josefin Sans"/>
-              </a:rPr>
-              <a:t>• Estudiantes Activos: Reciben alertas tempranas, orientación preventiva y simulan entrevistas laborales con retroalimentación instantánea.</a:t>
+              <a:rPr sz="1200" b="0" i="0" dirty="0">
+                <a:solidFill>
+                  <a:srgbClr val="323232"/>
+                </a:solidFill>
+                <a:latin typeface="Josefin Sans"/>
+              </a:rPr>
+              <a:t>• </a:t>
+            </a:r>
+            <a:r>
+              <a:rPr sz="1200" b="0" i="0" dirty="0" err="1">
+                <a:solidFill>
+                  <a:srgbClr val="323232"/>
+                </a:solidFill>
+                <a:latin typeface="Josefin Sans"/>
+              </a:rPr>
+              <a:t>Estudiantes</a:t>
+            </a:r>
+            <a:r>
+              <a:rPr sz="1200" b="0" i="0" dirty="0">
+                <a:solidFill>
+                  <a:srgbClr val="323232"/>
+                </a:solidFill>
+                <a:latin typeface="Josefin Sans"/>
+              </a:rPr>
+              <a:t> Activos: </a:t>
+            </a:r>
+            <a:r>
+              <a:rPr sz="1200" b="0" i="0" dirty="0" err="1">
+                <a:solidFill>
+                  <a:srgbClr val="323232"/>
+                </a:solidFill>
+                <a:latin typeface="Josefin Sans"/>
+              </a:rPr>
+              <a:t>Reciben</a:t>
+            </a:r>
+            <a:r>
+              <a:rPr sz="1200" b="0" i="0" dirty="0">
+                <a:solidFill>
+                  <a:srgbClr val="323232"/>
+                </a:solidFill>
+                <a:latin typeface="Josefin Sans"/>
+              </a:rPr>
+              <a:t> </a:t>
+            </a:r>
+            <a:r>
+              <a:rPr sz="1200" b="0" i="0" dirty="0" err="1">
+                <a:solidFill>
+                  <a:srgbClr val="323232"/>
+                </a:solidFill>
+                <a:latin typeface="Josefin Sans"/>
+              </a:rPr>
+              <a:t>alertas</a:t>
+            </a:r>
+            <a:r>
+              <a:rPr sz="1200" b="0" i="0" dirty="0">
+                <a:solidFill>
+                  <a:srgbClr val="323232"/>
+                </a:solidFill>
+                <a:latin typeface="Josefin Sans"/>
+              </a:rPr>
+              <a:t> </a:t>
+            </a:r>
+            <a:r>
+              <a:rPr sz="1200" b="0" i="0" dirty="0" err="1">
+                <a:solidFill>
+                  <a:srgbClr val="323232"/>
+                </a:solidFill>
+                <a:latin typeface="Josefin Sans"/>
+              </a:rPr>
+              <a:t>tempranas</a:t>
+            </a:r>
+            <a:r>
+              <a:rPr sz="1200" b="0" i="0" dirty="0">
+                <a:solidFill>
+                  <a:srgbClr val="323232"/>
+                </a:solidFill>
+                <a:latin typeface="Josefin Sans"/>
+              </a:rPr>
+              <a:t>, </a:t>
+            </a:r>
+            <a:r>
+              <a:rPr sz="1200" b="0" i="0" dirty="0" err="1">
+                <a:solidFill>
+                  <a:srgbClr val="323232"/>
+                </a:solidFill>
+                <a:latin typeface="Josefin Sans"/>
+              </a:rPr>
+              <a:t>orientación</a:t>
+            </a:r>
+            <a:r>
+              <a:rPr sz="1200" b="0" i="0" dirty="0">
+                <a:solidFill>
+                  <a:srgbClr val="323232"/>
+                </a:solidFill>
+                <a:latin typeface="Josefin Sans"/>
+              </a:rPr>
+              <a:t> </a:t>
+            </a:r>
+            <a:r>
+              <a:rPr sz="1200" b="0" i="0" dirty="0" err="1">
+                <a:solidFill>
+                  <a:srgbClr val="323232"/>
+                </a:solidFill>
+                <a:latin typeface="Josefin Sans"/>
+              </a:rPr>
+              <a:t>preventiva</a:t>
+            </a:r>
+            <a:r>
+              <a:rPr sz="1200" b="0" i="0" dirty="0">
+                <a:solidFill>
+                  <a:srgbClr val="323232"/>
+                </a:solidFill>
+                <a:latin typeface="Josefin Sans"/>
+              </a:rPr>
+              <a:t> y </a:t>
+            </a:r>
+            <a:r>
+              <a:rPr sz="1200" b="0" i="0" dirty="0" err="1">
+                <a:solidFill>
+                  <a:srgbClr val="323232"/>
+                </a:solidFill>
+                <a:latin typeface="Josefin Sans"/>
+              </a:rPr>
+              <a:t>simulan</a:t>
+            </a:r>
+            <a:r>
+              <a:rPr sz="1200" b="0" i="0" dirty="0">
+                <a:solidFill>
+                  <a:srgbClr val="323232"/>
+                </a:solidFill>
+                <a:latin typeface="Josefin Sans"/>
+              </a:rPr>
+              <a:t> </a:t>
+            </a:r>
+            <a:r>
+              <a:rPr sz="1200" b="0" i="0" dirty="0" err="1">
+                <a:solidFill>
+                  <a:srgbClr val="323232"/>
+                </a:solidFill>
+                <a:latin typeface="Josefin Sans"/>
+              </a:rPr>
+              <a:t>entrevistas</a:t>
+            </a:r>
+            <a:r>
+              <a:rPr sz="1200" b="0" i="0" dirty="0">
+                <a:solidFill>
+                  <a:srgbClr val="323232"/>
+                </a:solidFill>
+                <a:latin typeface="Josefin Sans"/>
+              </a:rPr>
+              <a:t> </a:t>
+            </a:r>
+            <a:r>
+              <a:rPr sz="1200" b="0" i="0" dirty="0" err="1">
+                <a:solidFill>
+                  <a:srgbClr val="323232"/>
+                </a:solidFill>
+                <a:latin typeface="Josefin Sans"/>
+              </a:rPr>
+              <a:t>laborales</a:t>
+            </a:r>
+            <a:r>
+              <a:rPr sz="1200" b="0" i="0" dirty="0">
+                <a:solidFill>
+                  <a:srgbClr val="323232"/>
+                </a:solidFill>
+                <a:latin typeface="Josefin Sans"/>
+              </a:rPr>
+              <a:t> con </a:t>
+            </a:r>
+            <a:r>
+              <a:rPr sz="1200" b="0" i="0" dirty="0" err="1">
+                <a:solidFill>
+                  <a:srgbClr val="323232"/>
+                </a:solidFill>
+                <a:latin typeface="Josefin Sans"/>
+              </a:rPr>
+              <a:t>retroalimentación</a:t>
+            </a:r>
+            <a:r>
+              <a:rPr sz="1200" b="0" i="0" dirty="0">
+                <a:solidFill>
+                  <a:srgbClr val="323232"/>
+                </a:solidFill>
+                <a:latin typeface="Josefin Sans"/>
+              </a:rPr>
+              <a:t> </a:t>
+            </a:r>
+            <a:r>
+              <a:rPr sz="1200" b="0" i="0" dirty="0" err="1">
+                <a:solidFill>
+                  <a:srgbClr val="323232"/>
+                </a:solidFill>
+                <a:latin typeface="Josefin Sans"/>
+              </a:rPr>
+              <a:t>instantánea</a:t>
+            </a:r>
+            <a:r>
+              <a:rPr sz="1200" b="0" i="0" dirty="0">
+                <a:solidFill>
+                  <a:srgbClr val="323232"/>
+                </a:solidFill>
+                <a:latin typeface="Josefin Sans"/>
+              </a:rPr>
+              <a:t>.</a:t>
             </a:r>
           </a:p>
           <a:p>
@@ -9902,13 +10637,85 @@
               </a:spcAft>
             </a:pPr>
             <a:r>
-              <a:rPr sz="1200" b="0" i="0">
-                <a:solidFill>
-                  <a:srgbClr val="323232"/>
-                </a:solidFill>
-                <a:latin typeface="Josefin Sans"/>
-              </a:rPr>
-              <a:t>• Egresados: Canal activo de mentoría y networking formativo.</a:t>
+              <a:rPr sz="1200" b="0" i="0" dirty="0">
+                <a:solidFill>
+                  <a:srgbClr val="323232"/>
+                </a:solidFill>
+                <a:latin typeface="Josefin Sans"/>
+              </a:rPr>
+              <a:t>• </a:t>
+            </a:r>
+            <a:r>
+              <a:rPr sz="1200" b="0" i="0" dirty="0" err="1">
+                <a:solidFill>
+                  <a:srgbClr val="323232"/>
+                </a:solidFill>
+                <a:latin typeface="Josefin Sans"/>
+              </a:rPr>
+              <a:t>Egresados</a:t>
+            </a:r>
+            <a:r>
+              <a:rPr sz="1200" b="0" i="0" dirty="0">
+                <a:solidFill>
+                  <a:srgbClr val="323232"/>
+                </a:solidFill>
+                <a:latin typeface="Josefin Sans"/>
+              </a:rPr>
+              <a:t>: Canal </a:t>
+            </a:r>
+            <a:r>
+              <a:rPr sz="1200" b="0" i="0" dirty="0" err="1">
+                <a:solidFill>
+                  <a:srgbClr val="323232"/>
+                </a:solidFill>
+                <a:latin typeface="Josefin Sans"/>
+              </a:rPr>
+              <a:t>activo</a:t>
+            </a:r>
+            <a:r>
+              <a:rPr sz="1200" b="0" i="0" dirty="0">
+                <a:solidFill>
+                  <a:srgbClr val="323232"/>
+                </a:solidFill>
+                <a:latin typeface="Josefin Sans"/>
+              </a:rPr>
+              <a:t> de </a:t>
+            </a:r>
+            <a:r>
+              <a:rPr sz="1200" b="0" i="0" dirty="0" err="1">
+                <a:solidFill>
+                  <a:srgbClr val="323232"/>
+                </a:solidFill>
+                <a:latin typeface="Josefin Sans"/>
+              </a:rPr>
+              <a:t>mentoría</a:t>
+            </a:r>
+            <a:r>
+              <a:rPr sz="1200" b="0" i="0" dirty="0">
+                <a:solidFill>
+                  <a:srgbClr val="323232"/>
+                </a:solidFill>
+                <a:latin typeface="Josefin Sans"/>
+              </a:rPr>
+              <a:t> y networking </a:t>
+            </a:r>
+            <a:r>
+              <a:rPr sz="1200" b="0" i="0" dirty="0" err="1">
+                <a:solidFill>
+                  <a:srgbClr val="323232"/>
+                </a:solidFill>
+                <a:latin typeface="Josefin Sans"/>
+              </a:rPr>
+              <a:t>formativo</a:t>
+            </a:r>
+            <a:r>
+              <a:rPr sz="1200" b="0" i="0" dirty="0">
+                <a:solidFill>
+                  <a:srgbClr val="323232"/>
+                </a:solidFill>
+                <a:latin typeface="Josefin Sans"/>
+              </a:rPr>
+              <a:t>.</a:t>
             </a:r>
           </a:p>
           <a:p>
@@ -9924,7 +10731,7 @@
               </a:spcAft>
             </a:pPr>
             <a:r>
-              <a:rPr sz="1250" b="1" i="0">
+              <a:rPr sz="1250" b="1" i="0" dirty="0">
                 <a:solidFill>
                   <a:srgbClr val="323232"/>
                 </a:solidFill>
@@ -9946,13 +10753,157 @@
               </a:spcAft>
             </a:pPr>
             <a:r>
-              <a:rPr sz="1200" b="0" i="0">
-                <a:solidFill>
-                  <a:srgbClr val="323232"/>
-                </a:solidFill>
-                <a:latin typeface="Josefin Sans"/>
-              </a:rPr>
-              <a:t>• 80 IES técnicas y tecnológicas en Bogotá y Cundinamarca con alta deserción en los primeros 3 semestres.</a:t>
+              <a:rPr sz="1200" b="0" i="0" dirty="0">
+                <a:solidFill>
+                  <a:srgbClr val="323232"/>
+                </a:solidFill>
+                <a:latin typeface="Josefin Sans"/>
+              </a:rPr>
+              <a:t>• 80 IES </a:t>
+            </a:r>
+            <a:r>
+              <a:rPr sz="1200" b="0" i="0" dirty="0" err="1">
+                <a:solidFill>
+                  <a:srgbClr val="323232"/>
+                </a:solidFill>
+                <a:latin typeface="Josefin Sans"/>
+              </a:rPr>
+              <a:t>técnicas</a:t>
+            </a:r>
+            <a:r>
+              <a:rPr sz="1200" b="0" i="0" dirty="0">
+                <a:solidFill>
+                  <a:srgbClr val="323232"/>
+                </a:solidFill>
+                <a:latin typeface="Josefin Sans"/>
+              </a:rPr>
+              <a:t> y </a:t>
+            </a:r>
+            <a:r>
+              <a:rPr sz="1200" b="0" i="0" dirty="0" err="1">
+                <a:solidFill>
+                  <a:srgbClr val="323232"/>
+                </a:solidFill>
+                <a:latin typeface="Josefin Sans"/>
+              </a:rPr>
+              <a:t>tecnológicas</a:t>
+            </a:r>
+            <a:r>
+              <a:rPr sz="1200" b="0" i="0" dirty="0">
+                <a:solidFill>
+                  <a:srgbClr val="323232"/>
+                </a:solidFill>
+                <a:latin typeface="Josefin Sans"/>
+              </a:rPr>
+              <a:t> </a:t>
+            </a:r>
+            <a:r>
+              <a:rPr sz="1200" b="0" i="0" dirty="0" err="1">
+                <a:solidFill>
+                  <a:srgbClr val="323232"/>
+                </a:solidFill>
+                <a:latin typeface="Josefin Sans"/>
+              </a:rPr>
+              <a:t>en</a:t>
+            </a:r>
+            <a:r>
+              <a:rPr sz="1200" b="0" i="0" dirty="0">
+                <a:solidFill>
+                  <a:srgbClr val="323232"/>
+                </a:solidFill>
+                <a:latin typeface="Josefin Sans"/>
+              </a:rPr>
+              <a:t> Bogotá y Cundinamarca con </a:t>
+            </a:r>
+            <a:r>
+              <a:rPr sz="1200" b="0" i="0" dirty="0" err="1">
+                <a:solidFill>
+                  <a:srgbClr val="323232"/>
+                </a:solidFill>
+                <a:latin typeface="Josefin Sans"/>
+              </a:rPr>
+              <a:t>alta</a:t>
+            </a:r>
+            <a:r>
+              <a:rPr sz="1200" b="0" i="0" dirty="0">
+                <a:solidFill>
+                  <a:srgbClr val="323232"/>
+                </a:solidFill>
+                <a:latin typeface="Josefin Sans"/>
+              </a:rPr>
+              <a:t> </a:t>
+            </a:r>
+            <a:r>
+              <a:rPr sz="1200" b="0" i="0" dirty="0" err="1">
+                <a:solidFill>
+                  <a:srgbClr val="323232"/>
+                </a:solidFill>
+                <a:latin typeface="Josefin Sans"/>
+              </a:rPr>
+              <a:t>deserción</a:t>
+            </a:r>
+            <a:r>
+              <a:rPr sz="1200" b="0" i="0" dirty="0">
+                <a:solidFill>
+                  <a:srgbClr val="323232"/>
+                </a:solidFill>
+                <a:latin typeface="Josefin Sans"/>
+              </a:rPr>
+              <a:t> </a:t>
+            </a:r>
+            <a:r>
+              <a:rPr sz="1200" b="0" i="0" dirty="0" err="1">
+                <a:solidFill>
+                  <a:srgbClr val="323232"/>
+                </a:solidFill>
+                <a:latin typeface="Josefin Sans"/>
+              </a:rPr>
+              <a:t>en</a:t>
+            </a:r>
+            <a:r>
+              <a:rPr sz="1200" b="0" i="0" dirty="0">
+                <a:solidFill>
+                  <a:srgbClr val="323232"/>
+                </a:solidFill>
+                <a:latin typeface="Josefin Sans"/>
+              </a:rPr>
+              <a:t> </a:t>
+            </a:r>
+            <a:r>
+              <a:rPr sz="1200" b="0" i="0" dirty="0" err="1">
+                <a:solidFill>
+                  <a:srgbClr val="323232"/>
+                </a:solidFill>
+                <a:latin typeface="Josefin Sans"/>
+              </a:rPr>
+              <a:t>los</a:t>
+            </a:r>
+            <a:r>
+              <a:rPr sz="1200" b="0" i="0" dirty="0">
+                <a:solidFill>
+                  <a:srgbClr val="323232"/>
+                </a:solidFill>
+                <a:latin typeface="Josefin Sans"/>
+              </a:rPr>
+              <a:t> primeros 3 </a:t>
+            </a:r>
+            <a:r>
+              <a:rPr sz="1200" b="0" i="0" dirty="0" err="1">
+                <a:solidFill>
+                  <a:srgbClr val="323232"/>
+                </a:solidFill>
+                <a:latin typeface="Josefin Sans"/>
+              </a:rPr>
+              <a:t>semestres</a:t>
+            </a:r>
+            <a:r>
+              <a:rPr sz="1200" b="0" i="0" dirty="0">
+                <a:solidFill>
+                  <a:srgbClr val="323232"/>
+                </a:solidFill>
+                <a:latin typeface="Josefin Sans"/>
+              </a:rPr>
+              <a:t>.</a:t>
             </a:r>
           </a:p>
           <a:p>
@@ -9968,13 +10919,49 @@
               </a:spcAft>
             </a:pPr>
             <a:r>
-              <a:rPr sz="1100" b="0" i="1">
+              <a:rPr sz="1100" b="0" i="1" dirty="0">
                 <a:solidFill>
                   <a:srgbClr val="787878"/>
                 </a:solidFill>
                 <a:latin typeface="Josefin Sans"/>
               </a:rPr>
-              <a:t>(Tiempo sugerido: 1 minuto)</a:t>
+              <a:t>(Tiempo </a:t>
+            </a:r>
+            <a:r>
+              <a:rPr sz="1100" b="0" i="1" dirty="0" err="1">
+                <a:solidFill>
+                  <a:srgbClr val="787878"/>
+                </a:solidFill>
+                <a:latin typeface="Josefin Sans"/>
+              </a:rPr>
+              <a:t>sugerido</a:t>
+            </a:r>
+            <a:r>
+              <a:rPr sz="1100" b="0" i="1" dirty="0">
+                <a:solidFill>
+                  <a:srgbClr val="787878"/>
+                </a:solidFill>
+                <a:latin typeface="Josefin Sans"/>
+              </a:rPr>
+              <a:t>: 1 </a:t>
+            </a:r>
+            <a:r>
+              <a:rPr sz="1100" b="0" i="1" dirty="0" err="1">
+                <a:solidFill>
+                  <a:srgbClr val="787878"/>
+                </a:solidFill>
+                <a:latin typeface="Josefin Sans"/>
+              </a:rPr>
+              <a:t>minuto</a:t>
+            </a:r>
+            <a:r>
+              <a:rPr sz="1100" b="0" i="1" dirty="0">
+                <a:solidFill>
+                  <a:srgbClr val="787878"/>
+                </a:solidFill>
+                <a:latin typeface="Josefin Sans"/>
+              </a:rPr>
+              <a:t>)</a:t>
             </a:r>
           </a:p>
         </p:txBody>
@@ -12360,15 +13347,6 @@
 </file>
 
 <file path=customXml/item1.xml><?xml version="1.0" encoding="utf-8"?>
-<?mso-contentType ?>
-<FormTemplates xmlns="http://schemas.microsoft.com/sharepoint/v3/contenttype/forms">
-  <Display>DocumentLibraryForm</Display>
-  <Edit>DocumentLibraryForm</Edit>
-  <New>DocumentLibraryForm</New>
-</FormTemplates>
-</file>
-
-<file path=customXml/item2.xml><?xml version="1.0" encoding="utf-8"?>
 <p:properties xmlns:p="http://schemas.microsoft.com/office/2006/metadata/properties" xmlns:xsi="http://www.w3.org/2001/XMLSchema-instance" xmlns:pc="http://schemas.microsoft.com/office/infopath/2007/PartnerControls">
   <documentManagement>
     <_ip_UnifiedCompliancePolicyUIAction xmlns="http://schemas.microsoft.com/sharepoint/v3" xsi:nil="true"/>
@@ -12381,6 +13359,15 @@
     <FechayHora xmlns="edbb1c21-1b45-407e-8894-c97732534993" xsi:nil="true"/>
   </documentManagement>
 </p:properties>
+</file>
+
+<file path=customXml/item2.xml><?xml version="1.0" encoding="utf-8"?>
+<?mso-contentType ?>
+<FormTemplates xmlns="http://schemas.microsoft.com/sharepoint/v3/contenttype/forms">
+  <Display>DocumentLibraryForm</Display>
+  <Edit>DocumentLibraryForm</Edit>
+  <New>DocumentLibraryForm</New>
+</FormTemplates>
 </file>
 
 <file path=customXml/item3.xml><?xml version="1.0" encoding="utf-8"?>
@@ -12674,14 +13661,6 @@
 </file>
 
 <file path=customXml/itemProps1.xml><?xml version="1.0" encoding="utf-8"?>
-<ds:datastoreItem xmlns:ds="http://schemas.openxmlformats.org/officeDocument/2006/customXml" ds:itemID="{24793A44-C896-41D7-AA95-258C41799BE5}">
-  <ds:schemaRefs>
-    <ds:schemaRef ds:uri="http://schemas.microsoft.com/sharepoint/v3/contenttype/forms"/>
-  </ds:schemaRefs>
-</ds:datastoreItem>
-</file>
-
-<file path=customXml/itemProps2.xml><?xml version="1.0" encoding="utf-8"?>
 <ds:datastoreItem xmlns:ds="http://schemas.openxmlformats.org/officeDocument/2006/customXml" ds:itemID="{E607C22C-0ADE-4E74-9F22-92A5F804D7D0}">
   <ds:schemaRefs>
     <ds:schemaRef ds:uri="http://schemas.microsoft.com/sharepoint/v3"/>
@@ -12695,6 +13674,14 @@
     <ds:schemaRef ds:uri="http://schemas.microsoft.com/office/infopath/2007/PartnerControls"/>
     <ds:schemaRef ds:uri="41dd0a9e-964d-48c8-9389-7445c2a187f7"/>
     <ds:schemaRef ds:uri="http://purl.org/dc/dcmitype/"/>
+  </ds:schemaRefs>
+</ds:datastoreItem>
+</file>
+
+<file path=customXml/itemProps2.xml><?xml version="1.0" encoding="utf-8"?>
+<ds:datastoreItem xmlns:ds="http://schemas.openxmlformats.org/officeDocument/2006/customXml" ds:itemID="{24793A44-C896-41D7-AA95-258C41799BE5}">
+  <ds:schemaRefs>
+    <ds:schemaRef ds:uri="http://schemas.microsoft.com/sharepoint/v3/contenttype/forms"/>
   </ds:schemaRefs>
 </ds:datastoreItem>
 </file>

</xml_diff>